<commit_message>
docs(pitch): concise, fact-checked deck text and 3-minute script
Deck (slides 3-6; slides 1-2 and all images unchanged):
- shorter text (slide 3 from ~150 words to 2 lines); real-data results replace the mock
  'Bayside Roasters $8,000' example (Cumaica $20k + Sour Flour $25k, 148 exposed each,
  partial $5k to G.Rabbit); no claim that hubs are avoided; supply (not footfall) traversal
- layout: titles no longer collide with template headings/decorations; demo bullets no longer
  overlap the repo line; dark-grey text made readable; diagram no longer hides 'Architecture'
Script: ~325 spoken words for 3:00, matches the slides; Q&A corrected (SF registry, not Google
Places; honest hub answer; assumption range); repo link -> main.

Co-authored-by: Copilot <223556219+Copilot@users.noreply.github.com>
</commit_message>
<xml_diff>
--- a/presentation/grant_advisor_pitch_deck.pptx
+++ b/presentation/grant_advisor_pitch_deck.pptx
@@ -13863,7 +13863,7 @@
               <a:buNone/>
             </a:pPr>
             <a:r>
-              <a:rPr lang="en" sz="1200">
+              <a:rPr lang="en" sz="1500">
                 <a:solidFill>
                   <a:schemeClr val="lt1"/>
                 </a:solidFill>
@@ -13872,19 +13872,7 @@
                 <a:cs typeface="Google Sans Flex Medium"/>
                 <a:sym typeface="Google Sans Flex Medium"/>
               </a:rPr>
-              <a:t>Shifting small-business relief from isolated bailouts to systemic network resilience prevents single closures from spiraling into long-term commercial blight, safeguarding neighborhood tax bases and multiplying the protective reach of every public dollar. </a:t>
-            </a:r>
-            <a:r>
-              <a:rPr lang="en" sz="1200">
-                <a:solidFill>
-                  <a:schemeClr val="lt1"/>
-                </a:solidFill>
-                <a:latin typeface="Google Sans Flex"/>
-                <a:ea typeface="Google Sans Flex"/>
-                <a:cs typeface="Google Sans Flex"/>
-                <a:sym typeface="Google Sans Flex"/>
-              </a:rPr>
-              <a:t>City grant officers must allocate scarce emergency micro-grants across dozens of struggling small businesses, but traditional spreadsheet rankings evaluate applicants in isolation—completely missing the hidden local supply-chain and footfall dependencies where a single closure triggers a multi-hop cascade of secondary failures down the block.</a:t>
+              <a:t>A city has $50,000 and more applicants than money. Ranking them one by one misses the supply chains between them: one closure can push businesses 1–2 hops away into trouble.</a:t>
             </a:r>
             <a:endParaRPr sz="1200">
               <a:solidFill>
@@ -13906,7 +13894,7 @@
               <a:buNone/>
             </a:pPr>
             <a:r>
-              <a:rPr lang="en" sz="1200">
+              <a:rPr lang="en" sz="1500" b="1">
                 <a:solidFill>
                   <a:schemeClr val="lt1"/>
                 </a:solidFill>
@@ -13915,7 +13903,19 @@
                 <a:cs typeface="Google Sans Flex Medium"/>
                 <a:sym typeface="Google Sans Flex Medium"/>
               </a:rPr>
-              <a:t>Benefits: Municipal economic development officers and community lenders gain a defensible, network-aware advisor to allocate funds, directly protecting keystone suppliers, healthy downstream businesses 1–2 hops away, and residents in high-poverty neighborhoods (like SF's Central Market corridor) who rely on local storefronts for jobs and daily essentials.</a:t>
+              <a:t>Who benefits: </a:t>
+            </a:r>
+            <a:r>
+              <a:rPr lang="en" sz="1500" b="0">
+                <a:solidFill>
+                  <a:schemeClr val="lt1"/>
+                </a:solidFill>
+                <a:latin typeface="Google Sans Flex Medium"/>
+                <a:ea typeface="Google Sans Flex Medium"/>
+                <a:cs typeface="Google Sans Flex Medium"/>
+                <a:sym typeface="Google Sans Flex Medium"/>
+              </a:rPr>
+              <a:t>grant officers get a defensible, network-aware recommendation; residents of high-poverty corridors like SF's Central Market keep the storefronts they rely on.</a:t>
             </a:r>
             <a:endParaRPr sz="1200">
               <a:solidFill>
@@ -13937,7 +13937,7 @@
         </p:nvSpPr>
         <p:spPr>
           <a:xfrm>
-            <a:off x="457200" y="365760"/>
+            <a:off x="457200" y="45720"/>
             <a:ext cx="8229600" cy="731520"/>
           </a:xfrm>
           <a:prstGeom prst="rect">
@@ -13951,7 +13951,7 @@
           </a:bodyPr>
           <a:lstStyle/>
           <a:p>
-            <a:pPr>
+            <a:pPr algn="ctr">
               <a:defRPr sz="2200" b="1">
                 <a:solidFill>
                   <a:srgbClr val="1A73E8"/>
@@ -13959,7 +13959,7 @@
               </a:defRPr>
             </a:pPr>
             <a:r>
-              <a:t>The Problem: Isolated Bailouts vs. Systemic Network Resilience</a:t>
+              <a:t>The Problem: Relief That Ignores the Network</a:t>
             </a:r>
           </a:p>
         </p:txBody>
@@ -14101,28 +14101,36 @@
               <a:buNone/>
             </a:pPr>
             <a:r>
-              <a:rPr lang="en" sz="1100">
+              <a:rPr lang="en" sz="1100" b="1">
                 <a:solidFill>
                   <a:schemeClr val="lt1"/>
                 </a:solidFill>
               </a:rPr>
-              <a:t>Uses </a:t>
+              <a:t>Google ADK + Gemini</a:t>
             </a:r>
             <a:r>
-              <a:rPr b="1" lang="en" sz="1100">
+              <a:rPr lang="en" sz="1100" b="0">
                 <a:solidFill>
                   <a:schemeClr val="lt1"/>
                 </a:solidFill>
               </a:rPr>
-              <a:t>Google ADK, Gemini, and BigQuery Graph (GQL)</a:t>
+              <a:t> walk a </a:t>
             </a:r>
             <a:r>
-              <a:rPr lang="en" sz="1100">
+              <a:rPr lang="en" sz="1100" b="1">
                 <a:solidFill>
                   <a:schemeClr val="lt1"/>
                 </a:solidFill>
               </a:rPr>
-              <a:t> to trace multi-hop supply and footfall cascades, protecting entire neighborhood networks instead of isolated storefronts.</a:t>
+              <a:t>BigQuery property graph (multi-hop GQL)</a:t>
+            </a:r>
+            <a:r>
+              <a:rPr lang="en" sz="1100" b="0">
+                <a:solidFill>
+                  <a:schemeClr val="lt1"/>
+                </a:solidFill>
+              </a:rPr>
+              <a:t> to find every business a closure would expose.</a:t>
             </a:r>
             <a:endParaRPr sz="1200">
               <a:solidFill>
@@ -14270,7 +14278,7 @@
                   <a:schemeClr val="lt1"/>
                 </a:solidFill>
               </a:rPr>
-              <a:t>Grant officers enter a relief budget and scenario in plain English to compare applicants, visualize 2-hop dependency paths, and stress-test funding splits.</a:t>
+              <a:t>The officer sets a budget in the Grant Desk; the agent ranks the queue, traces the cascade and answers follow-up questions.</a:t>
             </a:r>
             <a:endParaRPr sz="1200">
               <a:solidFill>
@@ -14349,28 +14357,28 @@
               <a:buNone/>
             </a:pPr>
             <a:r>
-              <a:rPr lang="en" sz="1100">
+              <a:rPr lang="en" sz="1100" b="0">
                 <a:solidFill>
                   <a:schemeClr val="lt1"/>
                 </a:solidFill>
               </a:rPr>
-              <a:t>Generates a </a:t>
+              <a:t>A </a:t>
             </a:r>
             <a:r>
-              <a:rPr b="1" lang="en" sz="1100">
+              <a:rPr lang="en" sz="1100" b="1">
                 <a:solidFill>
                   <a:schemeClr val="lt1"/>
                 </a:solidFill>
               </a:rPr>
-              <a:t>sign-ready Grant Memo</a:t>
+              <a:t>Grant Memo</a:t>
             </a:r>
             <a:r>
-              <a:rPr lang="en" sz="1100">
+              <a:rPr lang="en" sz="1100" b="0">
                 <a:solidFill>
                   <a:schemeClr val="lt1"/>
                 </a:solidFill>
               </a:rPr>
-              <a:t> in minutes—naming who to fund, which downstream businesses are saved, and auditing for census-tract equity.</a:t>
+              <a:t>: who to fund, how much, which businesses it protects, why not the runner-up, plus an equity audit.</a:t>
             </a:r>
             <a:endParaRPr sz="1100">
               <a:solidFill>
@@ -14414,8 +14422,8 @@
         </p:nvSpPr>
         <p:spPr>
           <a:xfrm>
-            <a:off x="457200" y="365760"/>
-            <a:ext cx="8229600" cy="731520"/>
+            <a:off x="1965960" y="274320"/>
+            <a:ext cx="5212080" cy="731520"/>
           </a:xfrm>
           <a:prstGeom prst="rect">
             <a:avLst/>
@@ -14428,7 +14436,7 @@
           </a:bodyPr>
           <a:lstStyle/>
           <a:p>
-            <a:pPr>
+            <a:pPr algn="ctr">
               <a:defRPr sz="2200" b="1">
                 <a:solidFill>
                   <a:srgbClr val="1A73E8"/>
@@ -14436,7 +14444,7 @@
               </a:defRPr>
             </a:pPr>
             <a:r>
-              <a:t>The Solution: Network-Aware Autonomous Agent</a:t>
+              <a:t>A Network-Aware Grant Advisor</a:t>
             </a:r>
           </a:p>
         </p:txBody>
@@ -14511,18 +14519,6 @@
               <a:buNone/>
               <a:defRPr sz="1300"/>
             </a:pPr>
-            <a:r>
-              <a:rPr lang="en">
-                <a:solidFill>
-                  <a:schemeClr val="lt1"/>
-                </a:solidFill>
-                <a:latin typeface="Google Sans Flex Medium"/>
-                <a:ea typeface="Google Sans Flex Medium"/>
-                <a:cs typeface="Google Sans Flex Medium"/>
-                <a:sym typeface="Google Sans Flex Medium"/>
-              </a:rPr>
-              <a:t>APP</a:t>
-            </a:r>
             <a:br>
               <a:rPr lang="en">
                 <a:solidFill>
@@ -14535,13 +14531,28 @@
               </a:rPr>
             </a:br>
             <a:r>
-              <a:rPr lang="en" sz="1200" u="sng">
-                <a:solidFill>
-                  <a:schemeClr val="hlink"/>
-                </a:solidFill>
-                <a:hlinkClick r:id="rId3"/>
+              <a:rPr lang="en" b="1" sz="1200">
+                <a:solidFill>
+                  <a:schemeClr val="lt1"/>
+                </a:solidFill>
+                <a:latin typeface="Google Sans Flex Medium"/>
+                <a:ea typeface="Google Sans Flex Medium"/>
+                <a:cs typeface="Google Sans Flex Medium"/>
+                <a:sym typeface="Google Sans Flex Medium"/>
               </a:rPr>
-              <a:t>https://grant-desk-245858333498.us-central1.run.app/</a:t>
+              <a:t>App: </a:t>
+            </a:r>
+            <a:r>
+              <a:rPr lang="en" b="0" sz="1200">
+                <a:solidFill>
+                  <a:schemeClr val="lt1"/>
+                </a:solidFill>
+                <a:latin typeface="Google Sans Flex Medium"/>
+                <a:ea typeface="Google Sans Flex Medium"/>
+                <a:cs typeface="Google Sans Flex Medium"/>
+                <a:sym typeface="Google Sans Flex Medium"/>
+              </a:rPr>
+              <a:t>grant-desk (private Cloud Run service)</a:t>
             </a:r>
             <a:endParaRPr sz="1200">
               <a:solidFill>
@@ -14567,18 +14578,6 @@
               <a:buNone/>
               <a:defRPr sz="1300"/>
             </a:pPr>
-            <a:r>
-              <a:rPr lang="en">
-                <a:solidFill>
-                  <a:schemeClr val="lt1"/>
-                </a:solidFill>
-                <a:latin typeface="Google Sans Flex Medium"/>
-                <a:ea typeface="Google Sans Flex Medium"/>
-                <a:cs typeface="Google Sans Flex Medium"/>
-                <a:sym typeface="Google Sans Flex Medium"/>
-              </a:rPr>
-              <a:t>Data Source</a:t>
-            </a:r>
             <a:br>
               <a:rPr lang="en">
                 <a:solidFill>
@@ -14591,53 +14590,28 @@
               </a:rPr>
             </a:br>
             <a:r>
-              <a:rPr lang="en" sz="1200" u="sng">
-                <a:solidFill>
-                  <a:schemeClr val="hlink"/>
-                </a:solidFill>
-                <a:latin typeface="Google Sans Flex"/>
-                <a:ea typeface="Google Sans Flex"/>
-                <a:cs typeface="Google Sans Flex"/>
-                <a:sym typeface="Google Sans Flex"/>
-                <a:hlinkClick r:id="rId4"/>
+              <a:rPr lang="en" b="1" sz="1200">
+                <a:solidFill>
+                  <a:schemeClr val="lt1"/>
+                </a:solidFill>
+                <a:latin typeface="Google Sans Flex Medium"/>
+                <a:ea typeface="Google Sans Flex Medium"/>
+                <a:cs typeface="Google Sans Flex Medium"/>
+                <a:sym typeface="Google Sans Flex Medium"/>
               </a:rPr>
-              <a:t>Google Cloud</a:t>
+              <a:t>Data: </a:t>
             </a:r>
             <a:r>
-              <a:rPr lang="en" sz="1200">
+              <a:rPr lang="en" b="0" sz="1200">
                 <a:solidFill>
                   <a:schemeClr val="lt1"/>
                 </a:solidFill>
-                <a:latin typeface="Google Sans Flex"/>
-                <a:ea typeface="Google Sans Flex"/>
-                <a:cs typeface="Google Sans Flex"/>
-                <a:sym typeface="Google Sans Flex"/>
+                <a:latin typeface="Google Sans Flex Medium"/>
+                <a:ea typeface="Google Sans Flex Medium"/>
+                <a:cs typeface="Google Sans Flex Medium"/>
+                <a:sym typeface="Google Sans Flex Medium"/>
               </a:rPr>
-              <a:t> </a:t>
-            </a:r>
-            <a:r>
-              <a:rPr lang="en" sz="1200">
-                <a:solidFill>
-                  <a:schemeClr val="lt1"/>
-                </a:solidFill>
-                <a:latin typeface="Google Sans Flex"/>
-                <a:ea typeface="Google Sans Flex"/>
-                <a:cs typeface="Google Sans Flex"/>
-                <a:sym typeface="Google Sans Flex"/>
-              </a:rPr>
-              <a:t>assigned</a:t>
-            </a:r>
-            <a:r>
-              <a:rPr lang="en" sz="1200">
-                <a:solidFill>
-                  <a:schemeClr val="lt1"/>
-                </a:solidFill>
-                <a:latin typeface="Google Sans Flex"/>
-                <a:ea typeface="Google Sans Flex"/>
-                <a:cs typeface="Google Sans Flex"/>
-                <a:sym typeface="Google Sans Flex"/>
-              </a:rPr>
-              <a:t> to Team 3</a:t>
+              <a:t>BigQuery, 232 real Central Market businesses</a:t>
             </a:r>
             <a:endParaRPr sz="1200">
               <a:solidFill>
@@ -14664,7 +14638,7 @@
               <a:defRPr sz="1300"/>
             </a:pPr>
             <a:r>
-              <a:rPr lang="en" sz="1200">
+              <a:rPr lang="en" sz="1200" b="1">
                 <a:solidFill>
                   <a:schemeClr val="lt1"/>
                 </a:solidFill>
@@ -14673,7 +14647,19 @@
                 <a:cs typeface="Google Sans Flex"/>
                 <a:sym typeface="Google Sans Flex"/>
               </a:rPr>
-              <a:t>Git Repo - https://github.com/michael-shl/google-hackathon-trt3/tree/rc/1.0.0</a:t>
+              <a:t>Repo: </a:t>
+            </a:r>
+            <a:r>
+              <a:rPr lang="en" sz="1200" b="0">
+                <a:solidFill>
+                  <a:schemeClr val="lt1"/>
+                </a:solidFill>
+                <a:latin typeface="Google Sans Flex"/>
+                <a:ea typeface="Google Sans Flex"/>
+                <a:cs typeface="Google Sans Flex"/>
+                <a:sym typeface="Google Sans Flex"/>
+              </a:rPr>
+              <a:t>github.com/michael-shl/google-hackathon-trt3</a:t>
             </a:r>
             <a:endParaRPr sz="1200">
               <a:solidFill>
@@ -14839,7 +14825,7 @@
               </a:defRPr>
             </a:pPr>
             <a:r>
-              <a:t>Live Demonstration &amp; Deployment</a:t>
+              <a:t>Live Demo on Real Data</a:t>
             </a:r>
           </a:p>
         </p:txBody>
@@ -14852,7 +14838,7 @@
         </p:nvSpPr>
         <p:spPr>
           <a:xfrm>
-            <a:off x="457200" y="3108960"/>
+            <a:off x="457200" y="3429000"/>
             <a:ext cx="8229600" cy="1645920"/>
           </a:xfrm>
           <a:prstGeom prst="rect">
@@ -14874,7 +14860,12 @@
               </a:defRPr>
             </a:pPr>
             <a:r>
-              <a:t>Live Test Scenario ($50,000 Budget across 11 Applicants):</a:t>
+              <a:rPr>
+                <a:solidFill>
+                  <a:srgbClr val="E8EAED"/>
+                </a:solidFill>
+              </a:rPr>
+              <a:t>$50,000 across 11 applicants (simulated applications, real businesses):</a:t>
             </a:r>
           </a:p>
           <a:p>
@@ -14886,7 +14877,12 @@
               </a:defRPr>
             </a:pPr>
             <a:r>
-              <a:t>• Keystone Detection: Identifies Bayside Roasters ($8,000) whose closure threatens 4 downstream storefronts 1–2 hops out.</a:t>
+              <a:rPr>
+                <a:solidFill>
+                  <a:srgbClr val="E8EAED"/>
+                </a:solidFill>
+              </a:rPr>
+              <a:t>• Funds Cumaica Coffee $20k and Sour Flour $25k: each protects 148 businesses within 2 hops.</a:t>
             </a:r>
           </a:p>
           <a:p>
@@ -14898,7 +14894,12 @@
               </a:defRPr>
             </a:pPr>
             <a:r>
-              <a:t>• Multi-hop Graph Traversal: Uses BigQuery GQL to quantify indirect exposure that spreadsheets cannot see.</a:t>
+              <a:rPr>
+                <a:solidFill>
+                  <a:srgbClr val="E8EAED"/>
+                </a:solidFill>
+              </a:rPr>
+              <a:t>• Uses the whole budget: a partial $5k grant to G.Rabbit (18 businesses exposed).</a:t>
             </a:r>
           </a:p>
           <a:p>
@@ -14910,7 +14911,12 @@
               </a:defRPr>
             </a:pPr>
             <a:r>
-              <a:t>• Defensible Output: Generates 7-section Grant Memo with Graphviz visual, sensitivity bounds, and census equity audit.</a:t>
+              <a:rPr>
+                <a:solidFill>
+                  <a:srgbClr val="E8EAED"/>
+                </a:solidFill>
+              </a:rPr>
+              <a:t>• Every path comes from a live BigQuery GQL traversal, written up as a 7-section Grant Memo.</a:t>
             </a:r>
           </a:p>
         </p:txBody>
@@ -15003,8 +15009,8 @@
         </p:blipFill>
         <p:spPr>
           <a:xfrm>
-            <a:off x="457200" y="1051560"/>
-            <a:ext cx="8229600" cy="2926080"/>
+            <a:off x="1229868" y="1645920"/>
+            <a:ext cx="6684264" cy="2377440"/>
           </a:xfrm>
           <a:prstGeom prst="rect">
             <a:avLst/>
@@ -15045,7 +15051,7 @@
               </a:defRPr>
             </a:pPr>
             <a:r>
-              <a:t>System Architecture &amp; Engineering Rigor</a:t>
+              <a:t>Architecture &amp; Rigor</a:t>
             </a:r>
           </a:p>
         </p:txBody>
@@ -15058,7 +15064,7 @@
         </p:nvSpPr>
         <p:spPr>
           <a:xfrm>
-            <a:off x="457200" y="4114800"/>
+            <a:off x="457200" y="4069080"/>
             <a:ext cx="8229600" cy="731520"/>
           </a:xfrm>
           <a:prstGeom prst="rect">
@@ -15080,7 +15086,20 @@
               </a:defRPr>
             </a:pPr>
             <a:r>
-              <a:t>Engineering Highlights: Google Cloud Run (Private Services) | Gemini 2.5 Flash on Vertex AI | BigQuery Property Graph</a:t>
+              <a:rPr lang="en-US" b="1">
+                <a:solidFill>
+                  <a:srgbClr val="E8EAED"/>
+                </a:solidFill>
+              </a:rPr>
+              <a:t>Built on: </a:t>
+            </a:r>
+            <a:r>
+              <a:rPr lang="en-US" b="0">
+                <a:solidFill>
+                  <a:srgbClr val="E8EAED"/>
+                </a:solidFill>
+              </a:rPr>
+              <a:t>Cloud Run (private) · ADK + Gemini 2.5 Flash · MCP Toolbox · BigQuery property graph</a:t>
             </a:r>
           </a:p>
           <a:p>
@@ -15092,7 +15111,20 @@
               </a:defRPr>
             </a:pPr>
             <a:r>
-              <a:t>Rigor: Honest modeling of BEA supply rates vs. real SBA loans; hub discount to prevent false-positive centralities; full tract equity audit.</a:t>
+              <a:rPr lang="en-US" b="1">
+                <a:solidFill>
+                  <a:srgbClr val="E8EAED"/>
+                </a:solidFill>
+              </a:rPr>
+              <a:t>Rigor: </a:t>
+            </a:r>
+            <a:r>
+              <a:rPr lang="en-US" b="0">
+                <a:solidFill>
+                  <a:srgbClr val="E8EAED"/>
+                </a:solidFill>
+              </a:rPr>
+              <a:t>real vs modeled data labelled on every answer · grant effect stated with low / base / high settings · equity audit · 31 tests</a:t>
             </a:r>
           </a:p>
         </p:txBody>

</xml_diff>

<commit_message>
privacy: remove team roster slide (phone numbers, emails) from the repo deck
The public repo copy now has 5 slides; the full deck with the organizer roster stays in Google
Slides. Verified: no phone number or personal email left in the .pptx; opens in Keynote.

Co-authored-by: Copilot <223556219+Copilot@users.noreply.github.com>
</commit_message>
<xml_diff>
--- a/presentation/grant_advisor_pitch_deck.pptx
+++ b/presentation/grant_advisor_pitch_deck.pptx
@@ -10,7 +10,6 @@
   </p:notesMasterIdLst>
   <p:sldIdLst>
     <p:sldId id="256" r:id="rId8"/>
-    <p:sldId id="257" r:id="rId9"/>
     <p:sldId id="258" r:id="rId10"/>
     <p:sldId id="259" r:id="rId11"/>
     <p:sldId id="260" r:id="rId12"/>
@@ -772,105 +771,6 @@
       <p:sp>
         <p:nvSpPr>
           <p:cNvPr id="109" name="Google Shape;109;h52fa8b8a4798773f_0_130:notes"/>
-          <p:cNvSpPr txBox="1"/>
-          <p:nvPr>
-            <p:ph idx="1" type="body"/>
-          </p:nvPr>
-        </p:nvSpPr>
-        <p:spPr>
-          <a:xfrm>
-            <a:off x="685800" y="4343400"/>
-            <a:ext cx="5486400" cy="4114800"/>
-          </a:xfrm>
-          <a:prstGeom prst="rect">
-            <a:avLst/>
-          </a:prstGeom>
-        </p:spPr>
-        <p:txBody>
-          <a:bodyPr anchorCtr="0" anchor="t" bIns="91425" lIns="91425" spcFirstLastPara="1" rIns="91425" wrap="square" tIns="91425">
-            <a:noAutofit/>
-          </a:bodyPr>
-          <a:lstStyle/>
-          <a:p>
-            <a:pPr indent="0" lvl="0" marL="0" rtl="0" algn="l">
-              <a:spcBef>
-                <a:spcPts val="0"/>
-              </a:spcBef>
-              <a:spcAft>
-                <a:spcPts val="0"/>
-              </a:spcAft>
-              <a:buNone/>
-            </a:pPr>
-            <a:r>
-              <a:t/>
-            </a:r>
-            <a:endParaRPr/>
-          </a:p>
-        </p:txBody>
-      </p:sp>
-    </p:spTree>
-  </p:cSld>
-  <p:clrMapOvr>
-    <a:masterClrMapping/>
-  </p:clrMapOvr>
-</p:notes>
-</file>
-
-<file path=ppt/notesSlides/notesSlide2.xml><?xml version="1.0" encoding="utf-8"?>
-<p:notes xmlns:a="http://schemas.openxmlformats.org/drawingml/2006/main" xmlns:r="http://schemas.openxmlformats.org/officeDocument/2006/relationships" xmlns:mc="http://schemas.openxmlformats.org/markup-compatibility/2006" xmlns:mv="urn:schemas-microsoft-com:mac:vml" xmlns:p="http://schemas.openxmlformats.org/presentationml/2006/main" xmlns:c="http://schemas.openxmlformats.org/drawingml/2006/chart" xmlns:dgm="http://schemas.openxmlformats.org/drawingml/2006/diagram" xmlns:o="urn:schemas-microsoft-com:office:office" xmlns:v="urn:schemas-microsoft-com:vml" xmlns:pvml="urn:schemas-microsoft-com:office:powerpoint" xmlns:com="http://schemas.openxmlformats.org/drawingml/2006/compatibility" xmlns:p14="http://schemas.microsoft.com/office/powerpoint/2010/main" xmlns:p15="http://schemas.microsoft.com/office/powerpoint/2012/main" xmlns:ahyp="http://schemas.microsoft.com/office/drawing/2018/hyperlinkcolor" showMasterPhAnim="0" showMasterSp="0">
-  <p:cSld>
-    <p:spTree>
-      <p:nvGrpSpPr>
-        <p:cNvPr id="113" name="Shape 113"/>
-        <p:cNvGrpSpPr/>
-        <p:nvPr/>
-      </p:nvGrpSpPr>
-      <p:grpSpPr>
-        <a:xfrm>
-          <a:off x="0" y="0"/>
-          <a:ext cx="0" cy="0"/>
-          <a:chOff x="0" y="0"/>
-          <a:chExt cx="0" cy="0"/>
-        </a:xfrm>
-      </p:grpSpPr>
-      <p:sp>
-        <p:nvSpPr>
-          <p:cNvPr id="114" name="Google Shape;114;h52fa8b8a4798773f_0_134:notes"/>
-          <p:cNvSpPr/>
-          <p:nvPr>
-            <p:ph idx="2" type="sldImg"/>
-          </p:nvPr>
-        </p:nvSpPr>
-        <p:spPr>
-          <a:xfrm>
-            <a:off x="381300" y="685800"/>
-            <a:ext cx="6096000" cy="3429000"/>
-          </a:xfrm>
-          <a:custGeom>
-            <a:rect b="b" l="l" r="r" t="t"/>
-            <a:pathLst>
-              <a:path extrusionOk="0" h="120000" w="120000">
-                <a:moveTo>
-                  <a:pt x="0" y="0"/>
-                </a:moveTo>
-                <a:lnTo>
-                  <a:pt x="120000" y="0"/>
-                </a:lnTo>
-                <a:lnTo>
-                  <a:pt x="120000" y="120000"/>
-                </a:lnTo>
-                <a:lnTo>
-                  <a:pt x="0" y="120000"/>
-                </a:lnTo>
-                <a:close/>
-              </a:path>
-            </a:pathLst>
-          </a:custGeom>
-        </p:spPr>
-      </p:sp>
-      <p:sp>
-        <p:nvSpPr>
-          <p:cNvPr id="115" name="Google Shape;115;h52fa8b8a4798773f_0_134:notes"/>
           <p:cNvSpPr txBox="1"/>
           <p:nvPr>
             <p:ph idx="1" type="body"/>
@@ -10867,2835 +10767,6 @@
             <a:r>
               <a:t>Agents for Impact 2026 | Track: Main Street Relief | Corridor: Central Market, SF</a:t>
             </a:r>
-          </a:p>
-        </p:txBody>
-      </p:sp>
-    </p:spTree>
-  </p:cSld>
-  <p:clrMapOvr>
-    <a:masterClrMapping/>
-  </p:clrMapOvr>
-</p:sld>
-</file>
-
-<file path=ppt/slides/slide2.xml><?xml version="1.0" encoding="utf-8"?>
-<p:sld xmlns:a="http://schemas.openxmlformats.org/drawingml/2006/main" xmlns:r="http://schemas.openxmlformats.org/officeDocument/2006/relationships" xmlns:mc="http://schemas.openxmlformats.org/markup-compatibility/2006" xmlns:mv="urn:schemas-microsoft-com:mac:vml" xmlns:p="http://schemas.openxmlformats.org/presentationml/2006/main" xmlns:c="http://schemas.openxmlformats.org/drawingml/2006/chart" xmlns:dgm="http://schemas.openxmlformats.org/drawingml/2006/diagram" xmlns:o="urn:schemas-microsoft-com:office:office" xmlns:v="urn:schemas-microsoft-com:vml" xmlns:pvml="urn:schemas-microsoft-com:office:powerpoint" xmlns:com="http://schemas.openxmlformats.org/drawingml/2006/compatibility" xmlns:p14="http://schemas.microsoft.com/office/powerpoint/2010/main" xmlns:p15="http://schemas.microsoft.com/office/powerpoint/2012/main" xmlns:ahyp="http://schemas.microsoft.com/office/drawing/2018/hyperlinkcolor">
-  <p:cSld>
-    <p:bg>
-      <p:bgPr>
-        <a:solidFill>
-          <a:srgbClr val="121317"/>
-        </a:solidFill>
-      </p:bgPr>
-    </p:bg>
-    <p:spTree>
-      <p:nvGrpSpPr>
-        <p:cNvPr id="116" name="Shape 116"/>
-        <p:cNvGrpSpPr/>
-        <p:nvPr/>
-      </p:nvGrpSpPr>
-      <p:grpSpPr>
-        <a:xfrm>
-          <a:off x="0" y="0"/>
-          <a:ext cx="0" cy="0"/>
-          <a:chOff x="0" y="0"/>
-          <a:chExt cx="0" cy="0"/>
-        </a:xfrm>
-      </p:grpSpPr>
-      <p:graphicFrame>
-        <p:nvGraphicFramePr>
-          <p:cNvPr id="117" name="Google Shape;117;p28"/>
-          <p:cNvGraphicFramePr/>
-          <p:nvPr/>
-        </p:nvGraphicFramePr>
-        <p:xfrm>
-          <a:off x="577750" y="1357275"/>
-          <a:ext cx="3000000" cy="3000000"/>
-        </p:xfrm>
-        <a:graphic>
-          <a:graphicData uri="http://schemas.openxmlformats.org/drawingml/2006/table">
-            <a:tbl>
-              <a:tblPr>
-                <a:noFill/>
-                <a:tableStyleId>{28DAF0F1-305B-411C-B7D9-DB96C7EA302D}</a:tableStyleId>
-              </a:tblPr>
-              <a:tblGrid>
-                <a:gridCol w="1352950"/>
-                <a:gridCol w="1352950"/>
-                <a:gridCol w="1238050"/>
-                <a:gridCol w="1467825"/>
-                <a:gridCol w="1352950"/>
-                <a:gridCol w="1352950"/>
-              </a:tblGrid>
-              <a:tr h="399675">
-                <a:tc>
-                  <a:txBody>
-                    <a:bodyPr/>
-                    <a:lstStyle/>
-                    <a:p>
-                      <a:pPr indent="0" lvl="0" marL="0" rtl="0" algn="ctr">
-                        <a:spcBef>
-                          <a:spcPts val="0"/>
-                        </a:spcBef>
-                        <a:spcAft>
-                          <a:spcPts val="0"/>
-                        </a:spcAft>
-                        <a:buNone/>
-                      </a:pPr>
-                      <a:r>
-                        <a:rPr b="1" lang="en" sz="800">
-                          <a:solidFill>
-                            <a:schemeClr val="lt1"/>
-                          </a:solidFill>
-                          <a:latin typeface="Google Sans Flex"/>
-                          <a:ea typeface="Google Sans Flex"/>
-                          <a:cs typeface="Google Sans Flex"/>
-                          <a:sym typeface="Google Sans Flex"/>
-                        </a:rPr>
-                        <a:t>NAME </a:t>
-                      </a:r>
-                      <a:endParaRPr b="1" sz="800">
-                        <a:solidFill>
-                          <a:schemeClr val="lt1"/>
-                        </a:solidFill>
-                        <a:latin typeface="Google Sans Flex"/>
-                        <a:ea typeface="Google Sans Flex"/>
-                        <a:cs typeface="Google Sans Flex"/>
-                        <a:sym typeface="Google Sans Flex"/>
-                      </a:endParaRPr>
-                    </a:p>
-                  </a:txBody>
-                  <a:tcPr marT="91425" marB="91425" marR="91425" marL="91425" anchor="ctr">
-                    <a:lnL cap="flat" cmpd="sng" w="9525">
-                      <a:solidFill>
-                        <a:srgbClr val="9E9E9E"/>
-                      </a:solidFill>
-                      <a:prstDash val="solid"/>
-                      <a:round/>
-                      <a:headEnd len="sm" w="sm" type="none"/>
-                      <a:tailEnd len="sm" w="sm" type="none"/>
-                    </a:lnL>
-                    <a:lnR cap="flat" cmpd="sng" w="9525">
-                      <a:solidFill>
-                        <a:srgbClr val="9E9E9E"/>
-                      </a:solidFill>
-                      <a:prstDash val="solid"/>
-                      <a:round/>
-                      <a:headEnd len="sm" w="sm" type="none"/>
-                      <a:tailEnd len="sm" w="sm" type="none"/>
-                    </a:lnR>
-                    <a:lnT cap="flat" cmpd="sng" w="9525">
-                      <a:solidFill>
-                        <a:srgbClr val="9E9E9E"/>
-                      </a:solidFill>
-                      <a:prstDash val="solid"/>
-                      <a:round/>
-                      <a:headEnd len="sm" w="sm" type="none"/>
-                      <a:tailEnd len="sm" w="sm" type="none"/>
-                    </a:lnT>
-                    <a:lnB cap="flat" cmpd="sng" w="9525">
-                      <a:solidFill>
-                        <a:srgbClr val="9E9E9E"/>
-                      </a:solidFill>
-                      <a:prstDash val="solid"/>
-                      <a:round/>
-                      <a:headEnd len="sm" w="sm" type="none"/>
-                      <a:tailEnd len="sm" w="sm" type="none"/>
-                    </a:lnB>
-                  </a:tcPr>
-                </a:tc>
-                <a:tc>
-                  <a:txBody>
-                    <a:bodyPr/>
-                    <a:lstStyle/>
-                    <a:p>
-                      <a:pPr indent="0" lvl="0" marL="0" rtl="0" algn="ctr">
-                        <a:spcBef>
-                          <a:spcPts val="0"/>
-                        </a:spcBef>
-                        <a:spcAft>
-                          <a:spcPts val="0"/>
-                        </a:spcAft>
-                        <a:buClr>
-                          <a:schemeClr val="dk1"/>
-                        </a:buClr>
-                        <a:buSzPts val="1100"/>
-                        <a:buFont typeface="Arial"/>
-                        <a:buNone/>
-                      </a:pPr>
-                      <a:r>
-                        <a:rPr b="1" lang="en" sz="800">
-                          <a:solidFill>
-                            <a:schemeClr val="lt1"/>
-                          </a:solidFill>
-                          <a:latin typeface="Google Sans Flex"/>
-                          <a:ea typeface="Google Sans Flex"/>
-                          <a:cs typeface="Google Sans Flex"/>
-                          <a:sym typeface="Google Sans Flex"/>
-                        </a:rPr>
-                        <a:t>EMAIL</a:t>
-                      </a:r>
-                      <a:endParaRPr b="1" sz="800">
-                        <a:latin typeface="Google Sans Flex"/>
-                        <a:ea typeface="Google Sans Flex"/>
-                        <a:cs typeface="Google Sans Flex"/>
-                        <a:sym typeface="Google Sans Flex"/>
-                      </a:endParaRPr>
-                    </a:p>
-                  </a:txBody>
-                  <a:tcPr marT="91425" marB="91425" marR="91425" marL="91425" anchor="ctr">
-                    <a:lnL cap="flat" cmpd="sng" w="9525">
-                      <a:solidFill>
-                        <a:srgbClr val="9E9E9E"/>
-                      </a:solidFill>
-                      <a:prstDash val="solid"/>
-                      <a:round/>
-                      <a:headEnd len="sm" w="sm" type="none"/>
-                      <a:tailEnd len="sm" w="sm" type="none"/>
-                    </a:lnL>
-                    <a:lnR cap="flat" cmpd="sng" w="9525">
-                      <a:solidFill>
-                        <a:srgbClr val="9E9E9E"/>
-                      </a:solidFill>
-                      <a:prstDash val="solid"/>
-                      <a:round/>
-                      <a:headEnd len="sm" w="sm" type="none"/>
-                      <a:tailEnd len="sm" w="sm" type="none"/>
-                    </a:lnR>
-                    <a:lnT cap="flat" cmpd="sng" w="9525">
-                      <a:solidFill>
-                        <a:srgbClr val="9E9E9E"/>
-                      </a:solidFill>
-                      <a:prstDash val="solid"/>
-                      <a:round/>
-                      <a:headEnd len="sm" w="sm" type="none"/>
-                      <a:tailEnd len="sm" w="sm" type="none"/>
-                    </a:lnT>
-                    <a:lnB cap="flat" cmpd="sng" w="9525">
-                      <a:solidFill>
-                        <a:srgbClr val="9E9E9E"/>
-                      </a:solidFill>
-                      <a:prstDash val="solid"/>
-                      <a:round/>
-                      <a:headEnd len="sm" w="sm" type="none"/>
-                      <a:tailEnd len="sm" w="sm" type="none"/>
-                    </a:lnB>
-                  </a:tcPr>
-                </a:tc>
-                <a:tc>
-                  <a:txBody>
-                    <a:bodyPr/>
-                    <a:lstStyle/>
-                    <a:p>
-                      <a:pPr indent="0" lvl="0" marL="0" rtl="0" algn="ctr">
-                        <a:spcBef>
-                          <a:spcPts val="0"/>
-                        </a:spcBef>
-                        <a:spcAft>
-                          <a:spcPts val="0"/>
-                        </a:spcAft>
-                        <a:buClr>
-                          <a:schemeClr val="dk1"/>
-                        </a:buClr>
-                        <a:buSzPts val="1100"/>
-                        <a:buFont typeface="Arial"/>
-                        <a:buNone/>
-                      </a:pPr>
-                      <a:r>
-                        <a:rPr b="1" lang="en" sz="800">
-                          <a:solidFill>
-                            <a:schemeClr val="lt1"/>
-                          </a:solidFill>
-                          <a:latin typeface="Google Sans Flex"/>
-                          <a:ea typeface="Google Sans Flex"/>
-                          <a:cs typeface="Google Sans Flex"/>
-                          <a:sym typeface="Google Sans Flex"/>
-                        </a:rPr>
-                        <a:t>PHONE</a:t>
-                      </a:r>
-                      <a:endParaRPr b="1" sz="800">
-                        <a:latin typeface="Google Sans Flex"/>
-                        <a:ea typeface="Google Sans Flex"/>
-                        <a:cs typeface="Google Sans Flex"/>
-                        <a:sym typeface="Google Sans Flex"/>
-                      </a:endParaRPr>
-                    </a:p>
-                  </a:txBody>
-                  <a:tcPr marT="91425" marB="91425" marR="91425" marL="91425" anchor="ctr">
-                    <a:lnL cap="flat" cmpd="sng" w="9525">
-                      <a:solidFill>
-                        <a:srgbClr val="9E9E9E"/>
-                      </a:solidFill>
-                      <a:prstDash val="solid"/>
-                      <a:round/>
-                      <a:headEnd len="sm" w="sm" type="none"/>
-                      <a:tailEnd len="sm" w="sm" type="none"/>
-                    </a:lnL>
-                    <a:lnR cap="flat" cmpd="sng" w="9525">
-                      <a:solidFill>
-                        <a:srgbClr val="CCCCCC"/>
-                      </a:solidFill>
-                      <a:prstDash val="solid"/>
-                      <a:round/>
-                      <a:headEnd len="sm" w="sm" type="none"/>
-                      <a:tailEnd len="sm" w="sm" type="none"/>
-                    </a:lnR>
-                    <a:lnT cap="flat" cmpd="sng" w="9525">
-                      <a:solidFill>
-                        <a:srgbClr val="9E9E9E"/>
-                      </a:solidFill>
-                      <a:prstDash val="solid"/>
-                      <a:round/>
-                      <a:headEnd len="sm" w="sm" type="none"/>
-                      <a:tailEnd len="sm" w="sm" type="none"/>
-                    </a:lnT>
-                    <a:lnB cap="flat" cmpd="sng" w="9525">
-                      <a:solidFill>
-                        <a:srgbClr val="9E9E9E"/>
-                      </a:solidFill>
-                      <a:prstDash val="solid"/>
-                      <a:round/>
-                      <a:headEnd len="sm" w="sm" type="none"/>
-                      <a:tailEnd len="sm" w="sm" type="none"/>
-                    </a:lnB>
-                  </a:tcPr>
-                </a:tc>
-                <a:tc>
-                  <a:txBody>
-                    <a:bodyPr/>
-                    <a:lstStyle/>
-                    <a:p>
-                      <a:pPr indent="0" lvl="0" marL="0" rtl="0" algn="ctr">
-                        <a:lnSpc>
-                          <a:spcPct val="115000"/>
-                        </a:lnSpc>
-                        <a:spcBef>
-                          <a:spcPts val="0"/>
-                        </a:spcBef>
-                        <a:spcAft>
-                          <a:spcPts val="0"/>
-                        </a:spcAft>
-                        <a:buNone/>
-                      </a:pPr>
-                      <a:r>
-                        <a:rPr b="1" lang="en" sz="800">
-                          <a:solidFill>
-                            <a:schemeClr val="lt1"/>
-                          </a:solidFill>
-                          <a:latin typeface="Google Sans Flex"/>
-                          <a:ea typeface="Google Sans Flex"/>
-                          <a:cs typeface="Google Sans Flex"/>
-                          <a:sym typeface="Google Sans Flex"/>
-                        </a:rPr>
-                        <a:t>FILMING AVAILABILITY</a:t>
-                      </a:r>
-                      <a:endParaRPr b="1" sz="800">
-                        <a:solidFill>
-                          <a:schemeClr val="lt1"/>
-                        </a:solidFill>
-                        <a:latin typeface="Google Sans Flex"/>
-                        <a:ea typeface="Google Sans Flex"/>
-                        <a:cs typeface="Google Sans Flex"/>
-                        <a:sym typeface="Google Sans Flex"/>
-                      </a:endParaRPr>
-                    </a:p>
-                    <a:p>
-                      <a:pPr indent="0" lvl="0" marL="0" rtl="0" algn="ctr">
-                        <a:lnSpc>
-                          <a:spcPct val="115000"/>
-                        </a:lnSpc>
-                        <a:spcBef>
-                          <a:spcPts val="0"/>
-                        </a:spcBef>
-                        <a:spcAft>
-                          <a:spcPts val="0"/>
-                        </a:spcAft>
-                        <a:buNone/>
-                      </a:pPr>
-                      <a:r>
-                        <a:rPr lang="en" sz="600">
-                          <a:solidFill>
-                            <a:schemeClr val="lt1"/>
-                          </a:solidFill>
-                          <a:latin typeface="Google Sans Flex"/>
-                          <a:ea typeface="Google Sans Flex"/>
-                          <a:cs typeface="Google Sans Flex"/>
-                          <a:sym typeface="Google Sans Flex"/>
-                        </a:rPr>
-                        <a:t>(between 1-4PM on 10/21)</a:t>
-                      </a:r>
-                      <a:endParaRPr sz="600">
-                        <a:solidFill>
-                          <a:schemeClr val="lt1"/>
-                        </a:solidFill>
-                        <a:latin typeface="Google Sans Flex"/>
-                        <a:ea typeface="Google Sans Flex"/>
-                        <a:cs typeface="Google Sans Flex"/>
-                        <a:sym typeface="Google Sans Flex"/>
-                      </a:endParaRPr>
-                    </a:p>
-                  </a:txBody>
-                  <a:tcPr marT="19050" marB="19050" marR="28575" marL="28575" anchor="ctr">
-                    <a:lnL cap="flat" cmpd="sng" w="9525">
-                      <a:solidFill>
-                        <a:srgbClr val="CCCCCC"/>
-                      </a:solidFill>
-                      <a:prstDash val="solid"/>
-                      <a:round/>
-                      <a:headEnd len="sm" w="sm" type="none"/>
-                      <a:tailEnd len="sm" w="sm" type="none"/>
-                    </a:lnL>
-                    <a:lnR cap="flat" cmpd="sng" w="9525">
-                      <a:solidFill>
-                        <a:srgbClr val="CCCCCC"/>
-                      </a:solidFill>
-                      <a:prstDash val="solid"/>
-                      <a:round/>
-                      <a:headEnd len="sm" w="sm" type="none"/>
-                      <a:tailEnd len="sm" w="sm" type="none"/>
-                    </a:lnR>
-                    <a:lnT cap="flat" cmpd="sng" w="9525">
-                      <a:solidFill>
-                        <a:srgbClr val="CCCCCC"/>
-                      </a:solidFill>
-                      <a:prstDash val="solid"/>
-                      <a:round/>
-                      <a:headEnd len="sm" w="sm" type="none"/>
-                      <a:tailEnd len="sm" w="sm" type="none"/>
-                    </a:lnT>
-                    <a:lnB cap="flat" cmpd="sng" w="9525">
-                      <a:solidFill>
-                        <a:srgbClr val="CCCCCC"/>
-                      </a:solidFill>
-                      <a:prstDash val="solid"/>
-                      <a:round/>
-                      <a:headEnd len="sm" w="sm" type="none"/>
-                      <a:tailEnd len="sm" w="sm" type="none"/>
-                    </a:lnB>
-                  </a:tcPr>
-                </a:tc>
-                <a:tc>
-                  <a:txBody>
-                    <a:bodyPr/>
-                    <a:lstStyle/>
-                    <a:p>
-                      <a:pPr indent="0" lvl="0" marL="0" rtl="0" algn="ctr">
-                        <a:lnSpc>
-                          <a:spcPct val="115000"/>
-                        </a:lnSpc>
-                        <a:spcBef>
-                          <a:spcPts val="0"/>
-                        </a:spcBef>
-                        <a:spcAft>
-                          <a:spcPts val="0"/>
-                        </a:spcAft>
-                        <a:buNone/>
-                      </a:pPr>
-                      <a:r>
-                        <a:rPr b="1" lang="en" sz="800">
-                          <a:solidFill>
-                            <a:schemeClr val="lt1"/>
-                          </a:solidFill>
-                          <a:latin typeface="Google Sans Flex"/>
-                          <a:ea typeface="Google Sans Flex"/>
-                          <a:cs typeface="Google Sans Flex"/>
-                          <a:sym typeface="Google Sans Flex"/>
-                        </a:rPr>
-                        <a:t>PROJECT SHARING</a:t>
-                      </a:r>
-                      <a:endParaRPr b="1" sz="800">
-                        <a:solidFill>
-                          <a:schemeClr val="lt1"/>
-                        </a:solidFill>
-                        <a:latin typeface="Google Sans Flex"/>
-                        <a:ea typeface="Google Sans Flex"/>
-                        <a:cs typeface="Google Sans Flex"/>
-                        <a:sym typeface="Google Sans Flex"/>
-                      </a:endParaRPr>
-                    </a:p>
-                  </a:txBody>
-                  <a:tcPr marT="19050" marB="19050" marR="28575" marL="28575" anchor="ctr">
-                    <a:lnL cap="flat" cmpd="sng" w="9525">
-                      <a:solidFill>
-                        <a:srgbClr val="CCCCCC"/>
-                      </a:solidFill>
-                      <a:prstDash val="solid"/>
-                      <a:round/>
-                      <a:headEnd len="sm" w="sm" type="none"/>
-                      <a:tailEnd len="sm" w="sm" type="none"/>
-                    </a:lnL>
-                    <a:lnR cap="flat" cmpd="sng" w="9525">
-                      <a:solidFill>
-                        <a:srgbClr val="CCCCCC"/>
-                      </a:solidFill>
-                      <a:prstDash val="solid"/>
-                      <a:round/>
-                      <a:headEnd len="sm" w="sm" type="none"/>
-                      <a:tailEnd len="sm" w="sm" type="none"/>
-                    </a:lnR>
-                    <a:lnT cap="flat" cmpd="sng" w="9525">
-                      <a:solidFill>
-                        <a:srgbClr val="CCCCCC"/>
-                      </a:solidFill>
-                      <a:prstDash val="solid"/>
-                      <a:round/>
-                      <a:headEnd len="sm" w="sm" type="none"/>
-                      <a:tailEnd len="sm" w="sm" type="none"/>
-                    </a:lnT>
-                    <a:lnB cap="flat" cmpd="sng" w="9525">
-                      <a:solidFill>
-                        <a:srgbClr val="CCCCCC"/>
-                      </a:solidFill>
-                      <a:prstDash val="solid"/>
-                      <a:round/>
-                      <a:headEnd len="sm" w="sm" type="none"/>
-                      <a:tailEnd len="sm" w="sm" type="none"/>
-                    </a:lnB>
-                  </a:tcPr>
-                </a:tc>
-                <a:tc>
-                  <a:txBody>
-                    <a:bodyPr/>
-                    <a:lstStyle/>
-                    <a:p>
-                      <a:pPr indent="0" lvl="0" marL="0" rtl="0" algn="ctr">
-                        <a:spcBef>
-                          <a:spcPts val="0"/>
-                        </a:spcBef>
-                        <a:spcAft>
-                          <a:spcPts val="0"/>
-                        </a:spcAft>
-                        <a:buClr>
-                          <a:schemeClr val="dk1"/>
-                        </a:buClr>
-                        <a:buSzPts val="1100"/>
-                        <a:buFont typeface="Arial"/>
-                        <a:buNone/>
-                      </a:pPr>
-                      <a:r>
-                        <a:rPr b="1" lang="en" sz="800">
-                          <a:solidFill>
-                            <a:schemeClr val="lt1"/>
-                          </a:solidFill>
-                          <a:latin typeface="Google Sans Flex"/>
-                          <a:ea typeface="Google Sans Flex"/>
-                          <a:cs typeface="Google Sans Flex"/>
-                          <a:sym typeface="Google Sans Flex"/>
-                        </a:rPr>
-                        <a:t>SHARE WITH </a:t>
-                      </a:r>
-                      <a:br>
-                        <a:rPr b="1" lang="en" sz="800">
-                          <a:solidFill>
-                            <a:schemeClr val="lt1"/>
-                          </a:solidFill>
-                          <a:latin typeface="Google Sans Flex"/>
-                          <a:ea typeface="Google Sans Flex"/>
-                          <a:cs typeface="Google Sans Flex"/>
-                          <a:sym typeface="Google Sans Flex"/>
-                        </a:rPr>
-                      </a:br>
-                      <a:r>
-                        <a:rPr lang="en" sz="600">
-                          <a:solidFill>
-                            <a:schemeClr val="lt1"/>
-                          </a:solidFill>
-                          <a:latin typeface="Google Sans Flex"/>
-                          <a:ea typeface="Google Sans Flex"/>
-                          <a:cs typeface="Google Sans Flex"/>
-                          <a:sym typeface="Google Sans Flex"/>
-                        </a:rPr>
-                        <a:t>(provide emails)</a:t>
-                      </a:r>
-                      <a:endParaRPr sz="600">
-                        <a:latin typeface="Google Sans Flex"/>
-                        <a:ea typeface="Google Sans Flex"/>
-                        <a:cs typeface="Google Sans Flex"/>
-                        <a:sym typeface="Google Sans Flex"/>
-                      </a:endParaRPr>
-                    </a:p>
-                  </a:txBody>
-                  <a:tcPr marT="91425" marB="91425" marR="91425" marL="91425" anchor="ctr">
-                    <a:lnL cap="flat" cmpd="sng" w="9525">
-                      <a:solidFill>
-                        <a:srgbClr val="CCCCCC"/>
-                      </a:solidFill>
-                      <a:prstDash val="solid"/>
-                      <a:round/>
-                      <a:headEnd len="sm" w="sm" type="none"/>
-                      <a:tailEnd len="sm" w="sm" type="none"/>
-                    </a:lnL>
-                    <a:lnR cap="flat" cmpd="sng" w="9525">
-                      <a:solidFill>
-                        <a:srgbClr val="9E9E9E"/>
-                      </a:solidFill>
-                      <a:prstDash val="solid"/>
-                      <a:round/>
-                      <a:headEnd len="sm" w="sm" type="none"/>
-                      <a:tailEnd len="sm" w="sm" type="none"/>
-                    </a:lnR>
-                    <a:lnT cap="flat" cmpd="sng" w="9525">
-                      <a:solidFill>
-                        <a:srgbClr val="9E9E9E"/>
-                      </a:solidFill>
-                      <a:prstDash val="solid"/>
-                      <a:round/>
-                      <a:headEnd len="sm" w="sm" type="none"/>
-                      <a:tailEnd len="sm" w="sm" type="none"/>
-                    </a:lnT>
-                    <a:lnB cap="flat" cmpd="sng" w="9525">
-                      <a:solidFill>
-                        <a:srgbClr val="9E9E9E"/>
-                      </a:solidFill>
-                      <a:prstDash val="solid"/>
-                      <a:round/>
-                      <a:headEnd len="sm" w="sm" type="none"/>
-                      <a:tailEnd len="sm" w="sm" type="none"/>
-                    </a:lnB>
-                  </a:tcPr>
-                </a:tc>
-              </a:tr>
-              <a:tr h="371775">
-                <a:tc>
-                  <a:txBody>
-                    <a:bodyPr/>
-                    <a:lstStyle/>
-                    <a:p>
-                      <a:pPr indent="0" lvl="0" marL="0" rtl="0" algn="l">
-                        <a:spcBef>
-                          <a:spcPts val="0"/>
-                        </a:spcBef>
-                        <a:spcAft>
-                          <a:spcPts val="0"/>
-                        </a:spcAft>
-                        <a:buNone/>
-                      </a:pPr>
-                      <a:r>
-                        <a:rPr lang="en">
-                          <a:solidFill>
-                            <a:schemeClr val="lt1"/>
-                          </a:solidFill>
-                        </a:rPr>
-                        <a:t>Shihao Li</a:t>
-                      </a:r>
-                      <a:r>
-                        <a:rPr lang="en">
-                          <a:solidFill>
-                            <a:schemeClr val="lt1"/>
-                          </a:solidFill>
-                        </a:rPr>
-                        <a:t> </a:t>
-                      </a:r>
-                      <a:endParaRPr>
-                        <a:solidFill>
-                          <a:schemeClr val="lt1"/>
-                        </a:solidFill>
-                      </a:endParaRPr>
-                    </a:p>
-                  </a:txBody>
-                  <a:tcPr marT="91425" marB="91425" marR="91425" marL="91425">
-                    <a:lnL cap="flat" cmpd="sng" w="9525">
-                      <a:solidFill>
-                        <a:srgbClr val="9E9E9E"/>
-                      </a:solidFill>
-                      <a:prstDash val="solid"/>
-                      <a:round/>
-                      <a:headEnd len="sm" w="sm" type="none"/>
-                      <a:tailEnd len="sm" w="sm" type="none"/>
-                    </a:lnL>
-                    <a:lnR cap="flat" cmpd="sng" w="9525">
-                      <a:solidFill>
-                        <a:srgbClr val="9E9E9E"/>
-                      </a:solidFill>
-                      <a:prstDash val="solid"/>
-                      <a:round/>
-                      <a:headEnd len="sm" w="sm" type="none"/>
-                      <a:tailEnd len="sm" w="sm" type="none"/>
-                    </a:lnR>
-                    <a:lnT cap="flat" cmpd="sng" w="9525">
-                      <a:solidFill>
-                        <a:srgbClr val="9E9E9E"/>
-                      </a:solidFill>
-                      <a:prstDash val="solid"/>
-                      <a:round/>
-                      <a:headEnd len="sm" w="sm" type="none"/>
-                      <a:tailEnd len="sm" w="sm" type="none"/>
-                    </a:lnT>
-                    <a:lnB cap="flat" cmpd="sng" w="9525">
-                      <a:solidFill>
-                        <a:srgbClr val="9E9E9E"/>
-                      </a:solidFill>
-                      <a:prstDash val="solid"/>
-                      <a:round/>
-                      <a:headEnd len="sm" w="sm" type="none"/>
-                      <a:tailEnd len="sm" w="sm" type="none"/>
-                    </a:lnB>
-                  </a:tcPr>
-                </a:tc>
-                <a:tc>
-                  <a:txBody>
-                    <a:bodyPr/>
-                    <a:lstStyle/>
-                    <a:p>
-                      <a:pPr indent="0" lvl="0" marL="0" rtl="0" algn="l">
-                        <a:spcBef>
-                          <a:spcPts val="0"/>
-                        </a:spcBef>
-                        <a:spcAft>
-                          <a:spcPts val="0"/>
-                        </a:spcAft>
-                        <a:buNone/>
-                      </a:pPr>
-                      <a:r>
-                        <a:rPr lang="en" sz="1200">
-                          <a:solidFill>
-                            <a:schemeClr val="lt1"/>
-                          </a:solidFill>
-                        </a:rPr>
-                        <a:t>lish1998@gmail.com</a:t>
-                      </a:r>
-                      <a:endParaRPr sz="1200">
-                        <a:solidFill>
-                          <a:schemeClr val="lt1"/>
-                        </a:solidFill>
-                      </a:endParaRPr>
-                    </a:p>
-                  </a:txBody>
-                  <a:tcPr marT="91425" marB="91425" marR="91425" marL="91425">
-                    <a:lnL cap="flat" cmpd="sng" w="9525">
-                      <a:solidFill>
-                        <a:srgbClr val="9E9E9E"/>
-                      </a:solidFill>
-                      <a:prstDash val="solid"/>
-                      <a:round/>
-                      <a:headEnd len="sm" w="sm" type="none"/>
-                      <a:tailEnd len="sm" w="sm" type="none"/>
-                    </a:lnL>
-                    <a:lnR cap="flat" cmpd="sng" w="9525">
-                      <a:solidFill>
-                        <a:srgbClr val="9E9E9E"/>
-                      </a:solidFill>
-                      <a:prstDash val="solid"/>
-                      <a:round/>
-                      <a:headEnd len="sm" w="sm" type="none"/>
-                      <a:tailEnd len="sm" w="sm" type="none"/>
-                    </a:lnR>
-                    <a:lnT cap="flat" cmpd="sng" w="9525">
-                      <a:solidFill>
-                        <a:srgbClr val="9E9E9E"/>
-                      </a:solidFill>
-                      <a:prstDash val="solid"/>
-                      <a:round/>
-                      <a:headEnd len="sm" w="sm" type="none"/>
-                      <a:tailEnd len="sm" w="sm" type="none"/>
-                    </a:lnT>
-                    <a:lnB cap="flat" cmpd="sng" w="9525">
-                      <a:solidFill>
-                        <a:srgbClr val="9E9E9E"/>
-                      </a:solidFill>
-                      <a:prstDash val="solid"/>
-                      <a:round/>
-                      <a:headEnd len="sm" w="sm" type="none"/>
-                      <a:tailEnd len="sm" w="sm" type="none"/>
-                    </a:lnB>
-                  </a:tcPr>
-                </a:tc>
-                <a:tc>
-                  <a:txBody>
-                    <a:bodyPr/>
-                    <a:lstStyle/>
-                    <a:p>
-                      <a:pPr indent="0" lvl="0" marL="0" rtl="0" algn="l">
-                        <a:spcBef>
-                          <a:spcPts val="0"/>
-                        </a:spcBef>
-                        <a:spcAft>
-                          <a:spcPts val="0"/>
-                        </a:spcAft>
-                        <a:buNone/>
-                      </a:pPr>
-                      <a:r>
-                        <a:rPr lang="en" sz="1200">
-                          <a:solidFill>
-                            <a:schemeClr val="lt1"/>
-                          </a:solidFill>
-                        </a:rPr>
-                        <a:t>647-389-6899</a:t>
-                      </a:r>
-                      <a:endParaRPr sz="1200">
-                        <a:solidFill>
-                          <a:schemeClr val="lt1"/>
-                        </a:solidFill>
-                      </a:endParaRPr>
-                    </a:p>
-                  </a:txBody>
-                  <a:tcPr marT="91425" marB="91425" marR="91425" marL="91425">
-                    <a:lnL cap="flat" cmpd="sng" w="9525">
-                      <a:solidFill>
-                        <a:srgbClr val="9E9E9E"/>
-                      </a:solidFill>
-                      <a:prstDash val="solid"/>
-                      <a:round/>
-                      <a:headEnd len="sm" w="sm" type="none"/>
-                      <a:tailEnd len="sm" w="sm" type="none"/>
-                    </a:lnL>
-                    <a:lnR cap="flat" cmpd="sng" w="9525">
-                      <a:solidFill>
-                        <a:srgbClr val="CCCCCC"/>
-                      </a:solidFill>
-                      <a:prstDash val="solid"/>
-                      <a:round/>
-                      <a:headEnd len="sm" w="sm" type="none"/>
-                      <a:tailEnd len="sm" w="sm" type="none"/>
-                    </a:lnR>
-                    <a:lnT cap="flat" cmpd="sng" w="9525">
-                      <a:solidFill>
-                        <a:srgbClr val="9E9E9E"/>
-                      </a:solidFill>
-                      <a:prstDash val="solid"/>
-                      <a:round/>
-                      <a:headEnd len="sm" w="sm" type="none"/>
-                      <a:tailEnd len="sm" w="sm" type="none"/>
-                    </a:lnT>
-                    <a:lnB cap="flat" cmpd="sng" w="9525">
-                      <a:solidFill>
-                        <a:srgbClr val="9E9E9E"/>
-                      </a:solidFill>
-                      <a:prstDash val="solid"/>
-                      <a:round/>
-                      <a:headEnd len="sm" w="sm" type="none"/>
-                      <a:tailEnd len="sm" w="sm" type="none"/>
-                    </a:lnB>
-                  </a:tcPr>
-                </a:tc>
-                <a:tc>
-                  <a:txBody>
-                    <a:bodyPr/>
-                    <a:lstStyle/>
-                    <a:p>
-                      <a:pPr indent="0" lvl="0" marL="0" rtl="0" algn="ctr">
-                        <a:spcBef>
-                          <a:spcPts val="0"/>
-                        </a:spcBef>
-                        <a:spcAft>
-                          <a:spcPts val="0"/>
-                        </a:spcAft>
-                        <a:buNone/>
-                      </a:pPr>
-                      <a:r>
-                        <a:rPr lang="en">
-                          <a:solidFill>
-                            <a:schemeClr val="lt1"/>
-                          </a:solidFill>
-                        </a:rPr>
-                        <a:t>Yes</a:t>
-                      </a:r>
-                      <a:endParaRPr>
-                        <a:solidFill>
-                          <a:schemeClr val="lt1"/>
-                        </a:solidFill>
-                      </a:endParaRPr>
-                    </a:p>
-                  </a:txBody>
-                  <a:tcPr marT="19050" marB="19050" marR="28575" marL="28575">
-                    <a:lnL cap="flat" cmpd="sng" w="9525">
-                      <a:solidFill>
-                        <a:srgbClr val="CCCCCC"/>
-                      </a:solidFill>
-                      <a:prstDash val="solid"/>
-                      <a:round/>
-                      <a:headEnd len="sm" w="sm" type="none"/>
-                      <a:tailEnd len="sm" w="sm" type="none"/>
-                    </a:lnL>
-                    <a:lnR cap="flat" cmpd="sng" w="9525">
-                      <a:solidFill>
-                        <a:srgbClr val="CCCCCC"/>
-                      </a:solidFill>
-                      <a:prstDash val="solid"/>
-                      <a:round/>
-                      <a:headEnd len="sm" w="sm" type="none"/>
-                      <a:tailEnd len="sm" w="sm" type="none"/>
-                    </a:lnR>
-                    <a:lnT cap="flat" cmpd="sng" w="9525">
-                      <a:solidFill>
-                        <a:srgbClr val="CCCCCC"/>
-                      </a:solidFill>
-                      <a:prstDash val="solid"/>
-                      <a:round/>
-                      <a:headEnd len="sm" w="sm" type="none"/>
-                      <a:tailEnd len="sm" w="sm" type="none"/>
-                    </a:lnT>
-                    <a:lnB cap="flat" cmpd="sng" w="9525">
-                      <a:solidFill>
-                        <a:srgbClr val="CCCCCC"/>
-                      </a:solidFill>
-                      <a:prstDash val="solid"/>
-                      <a:round/>
-                      <a:headEnd len="sm" w="sm" type="none"/>
-                      <a:tailEnd len="sm" w="sm" type="none"/>
-                    </a:lnB>
-                  </a:tcPr>
-                </a:tc>
-                <a:tc>
-                  <a:txBody>
-                    <a:bodyPr/>
-                    <a:lstStyle/>
-                    <a:p>
-                      <a:pPr indent="0" lvl="0" marL="0" rtl="0" algn="ctr">
-                        <a:spcBef>
-                          <a:spcPts val="0"/>
-                        </a:spcBef>
-                        <a:spcAft>
-                          <a:spcPts val="0"/>
-                        </a:spcAft>
-                        <a:buNone/>
-                      </a:pPr>
-                      <a:r>
-                        <a:rPr i="1" lang="en">
-                          <a:solidFill>
-                            <a:schemeClr val="lt1"/>
-                          </a:solidFill>
-                        </a:rPr>
-                        <a:t>Yes</a:t>
-                      </a:r>
-                      <a:endParaRPr i="1">
-                        <a:solidFill>
-                          <a:schemeClr val="lt1"/>
-                        </a:solidFill>
-                      </a:endParaRPr>
-                    </a:p>
-                  </a:txBody>
-                  <a:tcPr marT="19050" marB="19050" marR="28575" marL="28575">
-                    <a:lnL cap="flat" cmpd="sng" w="9525">
-                      <a:solidFill>
-                        <a:srgbClr val="CCCCCC"/>
-                      </a:solidFill>
-                      <a:prstDash val="solid"/>
-                      <a:round/>
-                      <a:headEnd len="sm" w="sm" type="none"/>
-                      <a:tailEnd len="sm" w="sm" type="none"/>
-                    </a:lnL>
-                    <a:lnR cap="flat" cmpd="sng" w="9525">
-                      <a:solidFill>
-                        <a:srgbClr val="CCCCCC"/>
-                      </a:solidFill>
-                      <a:prstDash val="solid"/>
-                      <a:round/>
-                      <a:headEnd len="sm" w="sm" type="none"/>
-                      <a:tailEnd len="sm" w="sm" type="none"/>
-                    </a:lnR>
-                    <a:lnT cap="flat" cmpd="sng" w="9525">
-                      <a:solidFill>
-                        <a:srgbClr val="CCCCCC"/>
-                      </a:solidFill>
-                      <a:prstDash val="solid"/>
-                      <a:round/>
-                      <a:headEnd len="sm" w="sm" type="none"/>
-                      <a:tailEnd len="sm" w="sm" type="none"/>
-                    </a:lnT>
-                    <a:lnB cap="flat" cmpd="sng" w="9525">
-                      <a:solidFill>
-                        <a:srgbClr val="CCCCCC"/>
-                      </a:solidFill>
-                      <a:prstDash val="solid"/>
-                      <a:round/>
-                      <a:headEnd len="sm" w="sm" type="none"/>
-                      <a:tailEnd len="sm" w="sm" type="none"/>
-                    </a:lnB>
-                  </a:tcPr>
-                </a:tc>
-                <a:tc>
-                  <a:txBody>
-                    <a:bodyPr/>
-                    <a:lstStyle/>
-                    <a:p>
-                      <a:pPr indent="0" lvl="0" marL="0" rtl="0" algn="l">
-                        <a:spcBef>
-                          <a:spcPts val="0"/>
-                        </a:spcBef>
-                        <a:spcAft>
-                          <a:spcPts val="0"/>
-                        </a:spcAft>
-                        <a:buNone/>
-                      </a:pPr>
-                      <a:r>
-                        <a:t/>
-                      </a:r>
-                      <a:endParaRPr>
-                        <a:solidFill>
-                          <a:schemeClr val="lt1"/>
-                        </a:solidFill>
-                      </a:endParaRPr>
-                    </a:p>
-                  </a:txBody>
-                  <a:tcPr marT="91425" marB="91425" marR="91425" marL="91425">
-                    <a:lnL cap="flat" cmpd="sng" w="9525">
-                      <a:solidFill>
-                        <a:srgbClr val="CCCCCC"/>
-                      </a:solidFill>
-                      <a:prstDash val="solid"/>
-                      <a:round/>
-                      <a:headEnd len="sm" w="sm" type="none"/>
-                      <a:tailEnd len="sm" w="sm" type="none"/>
-                    </a:lnL>
-                    <a:lnR cap="flat" cmpd="sng" w="9525">
-                      <a:solidFill>
-                        <a:srgbClr val="9E9E9E"/>
-                      </a:solidFill>
-                      <a:prstDash val="solid"/>
-                      <a:round/>
-                      <a:headEnd len="sm" w="sm" type="none"/>
-                      <a:tailEnd len="sm" w="sm" type="none"/>
-                    </a:lnR>
-                    <a:lnT cap="flat" cmpd="sng" w="9525">
-                      <a:solidFill>
-                        <a:srgbClr val="9E9E9E"/>
-                      </a:solidFill>
-                      <a:prstDash val="solid"/>
-                      <a:round/>
-                      <a:headEnd len="sm" w="sm" type="none"/>
-                      <a:tailEnd len="sm" w="sm" type="none"/>
-                    </a:lnT>
-                    <a:lnB cap="flat" cmpd="sng" w="9525">
-                      <a:solidFill>
-                        <a:srgbClr val="9E9E9E"/>
-                      </a:solidFill>
-                      <a:prstDash val="solid"/>
-                      <a:round/>
-                      <a:headEnd len="sm" w="sm" type="none"/>
-                      <a:tailEnd len="sm" w="sm" type="none"/>
-                    </a:lnB>
-                  </a:tcPr>
-                </a:tc>
-              </a:tr>
-              <a:tr h="371775">
-                <a:tc>
-                  <a:txBody>
-                    <a:bodyPr/>
-                    <a:lstStyle/>
-                    <a:p>
-                      <a:pPr indent="0" lvl="0" marL="0" rtl="0" algn="l">
-                        <a:spcBef>
-                          <a:spcPts val="0"/>
-                        </a:spcBef>
-                        <a:spcAft>
-                          <a:spcPts val="0"/>
-                        </a:spcAft>
-                        <a:buNone/>
-                      </a:pPr>
-                      <a:r>
-                        <a:rPr lang="en">
-                          <a:solidFill>
-                            <a:schemeClr val="lt1"/>
-                          </a:solidFill>
-                        </a:rPr>
-                        <a:t>Daniel Wang</a:t>
-                      </a:r>
-                      <a:endParaRPr>
-                        <a:solidFill>
-                          <a:schemeClr val="lt1"/>
-                        </a:solidFill>
-                      </a:endParaRPr>
-                    </a:p>
-                  </a:txBody>
-                  <a:tcPr marT="91425" marB="91425" marR="91425" marL="91425">
-                    <a:lnL cap="flat" cmpd="sng" w="9525">
-                      <a:solidFill>
-                        <a:srgbClr val="9E9E9E"/>
-                      </a:solidFill>
-                      <a:prstDash val="solid"/>
-                      <a:round/>
-                      <a:headEnd len="sm" w="sm" type="none"/>
-                      <a:tailEnd len="sm" w="sm" type="none"/>
-                    </a:lnL>
-                    <a:lnR cap="flat" cmpd="sng" w="9525">
-                      <a:solidFill>
-                        <a:srgbClr val="9E9E9E"/>
-                      </a:solidFill>
-                      <a:prstDash val="solid"/>
-                      <a:round/>
-                      <a:headEnd len="sm" w="sm" type="none"/>
-                      <a:tailEnd len="sm" w="sm" type="none"/>
-                    </a:lnR>
-                    <a:lnT cap="flat" cmpd="sng" w="9525">
-                      <a:solidFill>
-                        <a:srgbClr val="9E9E9E"/>
-                      </a:solidFill>
-                      <a:prstDash val="solid"/>
-                      <a:round/>
-                      <a:headEnd len="sm" w="sm" type="none"/>
-                      <a:tailEnd len="sm" w="sm" type="none"/>
-                    </a:lnT>
-                    <a:lnB cap="flat" cmpd="sng" w="9525">
-                      <a:solidFill>
-                        <a:srgbClr val="9E9E9E"/>
-                      </a:solidFill>
-                      <a:prstDash val="solid"/>
-                      <a:round/>
-                      <a:headEnd len="sm" w="sm" type="none"/>
-                      <a:tailEnd len="sm" w="sm" type="none"/>
-                    </a:lnB>
-                  </a:tcPr>
-                </a:tc>
-                <a:tc>
-                  <a:txBody>
-                    <a:bodyPr/>
-                    <a:lstStyle/>
-                    <a:p>
-                      <a:pPr indent="0" lvl="0" marL="0" rtl="0" algn="l">
-                        <a:spcBef>
-                          <a:spcPts val="0"/>
-                        </a:spcBef>
-                        <a:spcAft>
-                          <a:spcPts val="0"/>
-                        </a:spcAft>
-                        <a:buNone/>
-                      </a:pPr>
-                      <a:r>
-                        <a:rPr lang="en" sz="1200">
-                          <a:solidFill>
-                            <a:schemeClr val="lt1"/>
-                          </a:solidFill>
-                        </a:rPr>
-                        <a:t>danielw.sas@gmail.com</a:t>
-                      </a:r>
-                      <a:endParaRPr sz="1200">
-                        <a:solidFill>
-                          <a:schemeClr val="lt1"/>
-                        </a:solidFill>
-                      </a:endParaRPr>
-                    </a:p>
-                  </a:txBody>
-                  <a:tcPr marT="91425" marB="91425" marR="91425" marL="91425">
-                    <a:lnL cap="flat" cmpd="sng" w="9525">
-                      <a:solidFill>
-                        <a:srgbClr val="9E9E9E"/>
-                      </a:solidFill>
-                      <a:prstDash val="solid"/>
-                      <a:round/>
-                      <a:headEnd len="sm" w="sm" type="none"/>
-                      <a:tailEnd len="sm" w="sm" type="none"/>
-                    </a:lnL>
-                    <a:lnR cap="flat" cmpd="sng" w="9525">
-                      <a:solidFill>
-                        <a:srgbClr val="9E9E9E"/>
-                      </a:solidFill>
-                      <a:prstDash val="solid"/>
-                      <a:round/>
-                      <a:headEnd len="sm" w="sm" type="none"/>
-                      <a:tailEnd len="sm" w="sm" type="none"/>
-                    </a:lnR>
-                    <a:lnT cap="flat" cmpd="sng" w="9525">
-                      <a:solidFill>
-                        <a:srgbClr val="9E9E9E"/>
-                      </a:solidFill>
-                      <a:prstDash val="solid"/>
-                      <a:round/>
-                      <a:headEnd len="sm" w="sm" type="none"/>
-                      <a:tailEnd len="sm" w="sm" type="none"/>
-                    </a:lnT>
-                    <a:lnB cap="flat" cmpd="sng" w="9525">
-                      <a:solidFill>
-                        <a:srgbClr val="9E9E9E"/>
-                      </a:solidFill>
-                      <a:prstDash val="solid"/>
-                      <a:round/>
-                      <a:headEnd len="sm" w="sm" type="none"/>
-                      <a:tailEnd len="sm" w="sm" type="none"/>
-                    </a:lnB>
-                  </a:tcPr>
-                </a:tc>
-                <a:tc>
-                  <a:txBody>
-                    <a:bodyPr/>
-                    <a:lstStyle/>
-                    <a:p>
-                      <a:pPr indent="0" lvl="0" marL="0" rtl="0" algn="l">
-                        <a:spcBef>
-                          <a:spcPts val="0"/>
-                        </a:spcBef>
-                        <a:spcAft>
-                          <a:spcPts val="0"/>
-                        </a:spcAft>
-                        <a:buNone/>
-                      </a:pPr>
-                      <a:r>
-                        <a:rPr lang="en" sz="1200">
-                          <a:solidFill>
-                            <a:schemeClr val="lt1"/>
-                          </a:solidFill>
-                        </a:rPr>
-                        <a:t>647-208-8762</a:t>
-                      </a:r>
-                      <a:endParaRPr sz="1200">
-                        <a:solidFill>
-                          <a:schemeClr val="lt1"/>
-                        </a:solidFill>
-                      </a:endParaRPr>
-                    </a:p>
-                  </a:txBody>
-                  <a:tcPr marT="91425" marB="91425" marR="91425" marL="91425">
-                    <a:lnL cap="flat" cmpd="sng" w="9525">
-                      <a:solidFill>
-                        <a:srgbClr val="9E9E9E"/>
-                      </a:solidFill>
-                      <a:prstDash val="solid"/>
-                      <a:round/>
-                      <a:headEnd len="sm" w="sm" type="none"/>
-                      <a:tailEnd len="sm" w="sm" type="none"/>
-                    </a:lnL>
-                    <a:lnR cap="flat" cmpd="sng" w="9525">
-                      <a:solidFill>
-                        <a:srgbClr val="CCCCCC"/>
-                      </a:solidFill>
-                      <a:prstDash val="solid"/>
-                      <a:round/>
-                      <a:headEnd len="sm" w="sm" type="none"/>
-                      <a:tailEnd len="sm" w="sm" type="none"/>
-                    </a:lnR>
-                    <a:lnT cap="flat" cmpd="sng" w="9525">
-                      <a:solidFill>
-                        <a:srgbClr val="9E9E9E"/>
-                      </a:solidFill>
-                      <a:prstDash val="solid"/>
-                      <a:round/>
-                      <a:headEnd len="sm" w="sm" type="none"/>
-                      <a:tailEnd len="sm" w="sm" type="none"/>
-                    </a:lnT>
-                    <a:lnB cap="flat" cmpd="sng" w="9525">
-                      <a:solidFill>
-                        <a:srgbClr val="9E9E9E"/>
-                      </a:solidFill>
-                      <a:prstDash val="solid"/>
-                      <a:round/>
-                      <a:headEnd len="sm" w="sm" type="none"/>
-                      <a:tailEnd len="sm" w="sm" type="none"/>
-                    </a:lnB>
-                  </a:tcPr>
-                </a:tc>
-                <a:tc>
-                  <a:txBody>
-                    <a:bodyPr/>
-                    <a:lstStyle/>
-                    <a:p>
-                      <a:pPr indent="0" lvl="0" marL="0" rtl="0" algn="ctr">
-                        <a:spcBef>
-                          <a:spcPts val="0"/>
-                        </a:spcBef>
-                        <a:spcAft>
-                          <a:spcPts val="0"/>
-                        </a:spcAft>
-                        <a:buNone/>
-                      </a:pPr>
-                      <a:r>
-                        <a:rPr lang="en">
-                          <a:solidFill>
-                            <a:schemeClr val="lt1"/>
-                          </a:solidFill>
-                        </a:rPr>
-                        <a:t>Yes</a:t>
-                      </a:r>
-                      <a:endParaRPr>
-                        <a:solidFill>
-                          <a:schemeClr val="lt1"/>
-                        </a:solidFill>
-                      </a:endParaRPr>
-                    </a:p>
-                  </a:txBody>
-                  <a:tcPr marT="19050" marB="19050" marR="28575" marL="28575">
-                    <a:lnL cap="flat" cmpd="sng" w="9525">
-                      <a:solidFill>
-                        <a:srgbClr val="CCCCCC"/>
-                      </a:solidFill>
-                      <a:prstDash val="solid"/>
-                      <a:round/>
-                      <a:headEnd len="sm" w="sm" type="none"/>
-                      <a:tailEnd len="sm" w="sm" type="none"/>
-                    </a:lnL>
-                    <a:lnR cap="flat" cmpd="sng" w="9525">
-                      <a:solidFill>
-                        <a:srgbClr val="CCCCCC"/>
-                      </a:solidFill>
-                      <a:prstDash val="solid"/>
-                      <a:round/>
-                      <a:headEnd len="sm" w="sm" type="none"/>
-                      <a:tailEnd len="sm" w="sm" type="none"/>
-                    </a:lnR>
-                    <a:lnT cap="flat" cmpd="sng" w="9525">
-                      <a:solidFill>
-                        <a:srgbClr val="CCCCCC"/>
-                      </a:solidFill>
-                      <a:prstDash val="solid"/>
-                      <a:round/>
-                      <a:headEnd len="sm" w="sm" type="none"/>
-                      <a:tailEnd len="sm" w="sm" type="none"/>
-                    </a:lnT>
-                    <a:lnB cap="flat" cmpd="sng" w="9525">
-                      <a:solidFill>
-                        <a:srgbClr val="CCCCCC"/>
-                      </a:solidFill>
-                      <a:prstDash val="solid"/>
-                      <a:round/>
-                      <a:headEnd len="sm" w="sm" type="none"/>
-                      <a:tailEnd len="sm" w="sm" type="none"/>
-                    </a:lnB>
-                  </a:tcPr>
-                </a:tc>
-                <a:tc>
-                  <a:txBody>
-                    <a:bodyPr/>
-                    <a:lstStyle/>
-                    <a:p>
-                      <a:pPr indent="0" lvl="0" marL="0" rtl="0" algn="ctr">
-                        <a:spcBef>
-                          <a:spcPts val="0"/>
-                        </a:spcBef>
-                        <a:spcAft>
-                          <a:spcPts val="0"/>
-                        </a:spcAft>
-                        <a:buNone/>
-                      </a:pPr>
-                      <a:r>
-                        <a:rPr lang="en">
-                          <a:solidFill>
-                            <a:schemeClr val="lt1"/>
-                          </a:solidFill>
-                        </a:rPr>
-                        <a:t>Yes</a:t>
-                      </a:r>
-                      <a:endParaRPr>
-                        <a:solidFill>
-                          <a:schemeClr val="lt1"/>
-                        </a:solidFill>
-                      </a:endParaRPr>
-                    </a:p>
-                  </a:txBody>
-                  <a:tcPr marT="19050" marB="19050" marR="28575" marL="28575">
-                    <a:lnL cap="flat" cmpd="sng" w="9525">
-                      <a:solidFill>
-                        <a:srgbClr val="CCCCCC"/>
-                      </a:solidFill>
-                      <a:prstDash val="solid"/>
-                      <a:round/>
-                      <a:headEnd len="sm" w="sm" type="none"/>
-                      <a:tailEnd len="sm" w="sm" type="none"/>
-                    </a:lnL>
-                    <a:lnR cap="flat" cmpd="sng" w="9525">
-                      <a:solidFill>
-                        <a:srgbClr val="CCCCCC"/>
-                      </a:solidFill>
-                      <a:prstDash val="solid"/>
-                      <a:round/>
-                      <a:headEnd len="sm" w="sm" type="none"/>
-                      <a:tailEnd len="sm" w="sm" type="none"/>
-                    </a:lnR>
-                    <a:lnT cap="flat" cmpd="sng" w="9525">
-                      <a:solidFill>
-                        <a:srgbClr val="CCCCCC"/>
-                      </a:solidFill>
-                      <a:prstDash val="solid"/>
-                      <a:round/>
-                      <a:headEnd len="sm" w="sm" type="none"/>
-                      <a:tailEnd len="sm" w="sm" type="none"/>
-                    </a:lnT>
-                    <a:lnB cap="flat" cmpd="sng" w="9525">
-                      <a:solidFill>
-                        <a:srgbClr val="CCCCCC"/>
-                      </a:solidFill>
-                      <a:prstDash val="solid"/>
-                      <a:round/>
-                      <a:headEnd len="sm" w="sm" type="none"/>
-                      <a:tailEnd len="sm" w="sm" type="none"/>
-                    </a:lnB>
-                  </a:tcPr>
-                </a:tc>
-                <a:tc>
-                  <a:txBody>
-                    <a:bodyPr/>
-                    <a:lstStyle/>
-                    <a:p>
-                      <a:pPr indent="0" lvl="0" marL="0" rtl="0" algn="l">
-                        <a:spcBef>
-                          <a:spcPts val="0"/>
-                        </a:spcBef>
-                        <a:spcAft>
-                          <a:spcPts val="0"/>
-                        </a:spcAft>
-                        <a:buNone/>
-                      </a:pPr>
-                      <a:r>
-                        <a:t/>
-                      </a:r>
-                      <a:endParaRPr>
-                        <a:solidFill>
-                          <a:schemeClr val="lt1"/>
-                        </a:solidFill>
-                      </a:endParaRPr>
-                    </a:p>
-                  </a:txBody>
-                  <a:tcPr marT="91425" marB="91425" marR="91425" marL="91425">
-                    <a:lnL cap="flat" cmpd="sng" w="9525">
-                      <a:solidFill>
-                        <a:srgbClr val="CCCCCC"/>
-                      </a:solidFill>
-                      <a:prstDash val="solid"/>
-                      <a:round/>
-                      <a:headEnd len="sm" w="sm" type="none"/>
-                      <a:tailEnd len="sm" w="sm" type="none"/>
-                    </a:lnL>
-                    <a:lnR cap="flat" cmpd="sng" w="9525">
-                      <a:solidFill>
-                        <a:srgbClr val="9E9E9E"/>
-                      </a:solidFill>
-                      <a:prstDash val="solid"/>
-                      <a:round/>
-                      <a:headEnd len="sm" w="sm" type="none"/>
-                      <a:tailEnd len="sm" w="sm" type="none"/>
-                    </a:lnR>
-                    <a:lnT cap="flat" cmpd="sng" w="9525">
-                      <a:solidFill>
-                        <a:srgbClr val="9E9E9E"/>
-                      </a:solidFill>
-                      <a:prstDash val="solid"/>
-                      <a:round/>
-                      <a:headEnd len="sm" w="sm" type="none"/>
-                      <a:tailEnd len="sm" w="sm" type="none"/>
-                    </a:lnT>
-                    <a:lnB cap="flat" cmpd="sng" w="9525">
-                      <a:solidFill>
-                        <a:srgbClr val="9E9E9E"/>
-                      </a:solidFill>
-                      <a:prstDash val="solid"/>
-                      <a:round/>
-                      <a:headEnd len="sm" w="sm" type="none"/>
-                      <a:tailEnd len="sm" w="sm" type="none"/>
-                    </a:lnB>
-                  </a:tcPr>
-                </a:tc>
-              </a:tr>
-              <a:tr h="338425">
-                <a:tc>
-                  <a:txBody>
-                    <a:bodyPr/>
-                    <a:lstStyle/>
-                    <a:p>
-                      <a:pPr indent="0" lvl="0" marL="0" rtl="0" algn="l">
-                        <a:spcBef>
-                          <a:spcPts val="0"/>
-                        </a:spcBef>
-                        <a:spcAft>
-                          <a:spcPts val="0"/>
-                        </a:spcAft>
-                        <a:buNone/>
-                      </a:pPr>
-                      <a:r>
-                        <a:rPr lang="en">
-                          <a:solidFill>
-                            <a:schemeClr val="lt1"/>
-                          </a:solidFill>
-                        </a:rPr>
-                        <a:t>Harmeet D</a:t>
-                      </a:r>
-                      <a:endParaRPr>
-                        <a:solidFill>
-                          <a:schemeClr val="lt1"/>
-                        </a:solidFill>
-                      </a:endParaRPr>
-                    </a:p>
-                  </a:txBody>
-                  <a:tcPr marT="91425" marB="91425" marR="91425" marL="91425">
-                    <a:lnL cap="flat" cmpd="sng" w="9525">
-                      <a:solidFill>
-                        <a:srgbClr val="9E9E9E"/>
-                      </a:solidFill>
-                      <a:prstDash val="solid"/>
-                      <a:round/>
-                      <a:headEnd len="sm" w="sm" type="none"/>
-                      <a:tailEnd len="sm" w="sm" type="none"/>
-                    </a:lnL>
-                    <a:lnR cap="flat" cmpd="sng" w="9525">
-                      <a:solidFill>
-                        <a:srgbClr val="9E9E9E"/>
-                      </a:solidFill>
-                      <a:prstDash val="solid"/>
-                      <a:round/>
-                      <a:headEnd len="sm" w="sm" type="none"/>
-                      <a:tailEnd len="sm" w="sm" type="none"/>
-                    </a:lnR>
-                    <a:lnT cap="flat" cmpd="sng" w="9525">
-                      <a:solidFill>
-                        <a:srgbClr val="9E9E9E"/>
-                      </a:solidFill>
-                      <a:prstDash val="solid"/>
-                      <a:round/>
-                      <a:headEnd len="sm" w="sm" type="none"/>
-                      <a:tailEnd len="sm" w="sm" type="none"/>
-                    </a:lnT>
-                    <a:lnB cap="flat" cmpd="sng" w="9525">
-                      <a:solidFill>
-                        <a:srgbClr val="9E9E9E"/>
-                      </a:solidFill>
-                      <a:prstDash val="solid"/>
-                      <a:round/>
-                      <a:headEnd len="sm" w="sm" type="none"/>
-                      <a:tailEnd len="sm" w="sm" type="none"/>
-                    </a:lnB>
-                  </a:tcPr>
-                </a:tc>
-                <a:tc>
-                  <a:txBody>
-                    <a:bodyPr/>
-                    <a:lstStyle/>
-                    <a:p>
-                      <a:pPr indent="0" lvl="0" marL="0" rtl="0" algn="l">
-                        <a:spcBef>
-                          <a:spcPts val="0"/>
-                        </a:spcBef>
-                        <a:spcAft>
-                          <a:spcPts val="0"/>
-                        </a:spcAft>
-                        <a:buNone/>
-                      </a:pPr>
-                      <a:r>
-                        <a:rPr lang="en" sz="1200">
-                          <a:solidFill>
-                            <a:schemeClr val="lt1"/>
-                          </a:solidFill>
-                        </a:rPr>
-                        <a:t>harmeet.kaur2711@gmail.com</a:t>
-                      </a:r>
-                      <a:endParaRPr sz="1200">
-                        <a:solidFill>
-                          <a:schemeClr val="lt1"/>
-                        </a:solidFill>
-                      </a:endParaRPr>
-                    </a:p>
-                  </a:txBody>
-                  <a:tcPr marT="91425" marB="91425" marR="91425" marL="91425">
-                    <a:lnL cap="flat" cmpd="sng" w="9525">
-                      <a:solidFill>
-                        <a:srgbClr val="9E9E9E"/>
-                      </a:solidFill>
-                      <a:prstDash val="solid"/>
-                      <a:round/>
-                      <a:headEnd len="sm" w="sm" type="none"/>
-                      <a:tailEnd len="sm" w="sm" type="none"/>
-                    </a:lnL>
-                    <a:lnR cap="flat" cmpd="sng" w="9525">
-                      <a:solidFill>
-                        <a:srgbClr val="9E9E9E"/>
-                      </a:solidFill>
-                      <a:prstDash val="solid"/>
-                      <a:round/>
-                      <a:headEnd len="sm" w="sm" type="none"/>
-                      <a:tailEnd len="sm" w="sm" type="none"/>
-                    </a:lnR>
-                    <a:lnT cap="flat" cmpd="sng" w="9525">
-                      <a:solidFill>
-                        <a:srgbClr val="9E9E9E"/>
-                      </a:solidFill>
-                      <a:prstDash val="solid"/>
-                      <a:round/>
-                      <a:headEnd len="sm" w="sm" type="none"/>
-                      <a:tailEnd len="sm" w="sm" type="none"/>
-                    </a:lnT>
-                    <a:lnB cap="flat" cmpd="sng" w="9525">
-                      <a:solidFill>
-                        <a:srgbClr val="9E9E9E"/>
-                      </a:solidFill>
-                      <a:prstDash val="solid"/>
-                      <a:round/>
-                      <a:headEnd len="sm" w="sm" type="none"/>
-                      <a:tailEnd len="sm" w="sm" type="none"/>
-                    </a:lnB>
-                  </a:tcPr>
-                </a:tc>
-                <a:tc>
-                  <a:txBody>
-                    <a:bodyPr/>
-                    <a:lstStyle/>
-                    <a:p>
-                      <a:pPr indent="0" lvl="0" marL="0" rtl="0" algn="l">
-                        <a:spcBef>
-                          <a:spcPts val="0"/>
-                        </a:spcBef>
-                        <a:spcAft>
-                          <a:spcPts val="0"/>
-                        </a:spcAft>
-                        <a:buNone/>
-                      </a:pPr>
-                      <a:r>
-                        <a:rPr lang="en" sz="1200">
-                          <a:solidFill>
-                            <a:schemeClr val="lt1"/>
-                          </a:solidFill>
-                        </a:rPr>
-                        <a:t>905-244-4392</a:t>
-                      </a:r>
-                      <a:endParaRPr sz="1200">
-                        <a:solidFill>
-                          <a:schemeClr val="lt1"/>
-                        </a:solidFill>
-                      </a:endParaRPr>
-                    </a:p>
-                  </a:txBody>
-                  <a:tcPr marT="91425" marB="91425" marR="91425" marL="91425">
-                    <a:lnL cap="flat" cmpd="sng" w="9525">
-                      <a:solidFill>
-                        <a:srgbClr val="9E9E9E"/>
-                      </a:solidFill>
-                      <a:prstDash val="solid"/>
-                      <a:round/>
-                      <a:headEnd len="sm" w="sm" type="none"/>
-                      <a:tailEnd len="sm" w="sm" type="none"/>
-                    </a:lnL>
-                    <a:lnR cap="flat" cmpd="sng" w="9525">
-                      <a:solidFill>
-                        <a:srgbClr val="CCCCCC"/>
-                      </a:solidFill>
-                      <a:prstDash val="solid"/>
-                      <a:round/>
-                      <a:headEnd len="sm" w="sm" type="none"/>
-                      <a:tailEnd len="sm" w="sm" type="none"/>
-                    </a:lnR>
-                    <a:lnT cap="flat" cmpd="sng" w="9525">
-                      <a:solidFill>
-                        <a:srgbClr val="9E9E9E"/>
-                      </a:solidFill>
-                      <a:prstDash val="solid"/>
-                      <a:round/>
-                      <a:headEnd len="sm" w="sm" type="none"/>
-                      <a:tailEnd len="sm" w="sm" type="none"/>
-                    </a:lnT>
-                    <a:lnB cap="flat" cmpd="sng" w="9525">
-                      <a:solidFill>
-                        <a:srgbClr val="9E9E9E"/>
-                      </a:solidFill>
-                      <a:prstDash val="solid"/>
-                      <a:round/>
-                      <a:headEnd len="sm" w="sm" type="none"/>
-                      <a:tailEnd len="sm" w="sm" type="none"/>
-                    </a:lnB>
-                  </a:tcPr>
-                </a:tc>
-                <a:tc>
-                  <a:txBody>
-                    <a:bodyPr/>
-                    <a:lstStyle/>
-                    <a:p>
-                      <a:pPr indent="0" lvl="0" marL="0" rtl="0" algn="ctr">
-                        <a:spcBef>
-                          <a:spcPts val="0"/>
-                        </a:spcBef>
-                        <a:spcAft>
-                          <a:spcPts val="0"/>
-                        </a:spcAft>
-                        <a:buNone/>
-                      </a:pPr>
-                      <a:r>
-                        <a:rPr lang="en">
-                          <a:solidFill>
-                            <a:schemeClr val="lt1"/>
-                          </a:solidFill>
-                        </a:rPr>
-                        <a:t>No</a:t>
-                      </a:r>
-                      <a:endParaRPr>
-                        <a:solidFill>
-                          <a:schemeClr val="lt1"/>
-                        </a:solidFill>
-                      </a:endParaRPr>
-                    </a:p>
-                  </a:txBody>
-                  <a:tcPr marT="19050" marB="19050" marR="28575" marL="28575">
-                    <a:lnL cap="flat" cmpd="sng" w="9525">
-                      <a:solidFill>
-                        <a:srgbClr val="CCCCCC"/>
-                      </a:solidFill>
-                      <a:prstDash val="solid"/>
-                      <a:round/>
-                      <a:headEnd len="sm" w="sm" type="none"/>
-                      <a:tailEnd len="sm" w="sm" type="none"/>
-                    </a:lnL>
-                    <a:lnR cap="flat" cmpd="sng" w="9525">
-                      <a:solidFill>
-                        <a:srgbClr val="CCCCCC"/>
-                      </a:solidFill>
-                      <a:prstDash val="solid"/>
-                      <a:round/>
-                      <a:headEnd len="sm" w="sm" type="none"/>
-                      <a:tailEnd len="sm" w="sm" type="none"/>
-                    </a:lnR>
-                    <a:lnT cap="flat" cmpd="sng" w="9525">
-                      <a:solidFill>
-                        <a:srgbClr val="CCCCCC"/>
-                      </a:solidFill>
-                      <a:prstDash val="solid"/>
-                      <a:round/>
-                      <a:headEnd len="sm" w="sm" type="none"/>
-                      <a:tailEnd len="sm" w="sm" type="none"/>
-                    </a:lnT>
-                    <a:lnB cap="flat" cmpd="sng" w="9525">
-                      <a:solidFill>
-                        <a:srgbClr val="CCCCCC"/>
-                      </a:solidFill>
-                      <a:prstDash val="solid"/>
-                      <a:round/>
-                      <a:headEnd len="sm" w="sm" type="none"/>
-                      <a:tailEnd len="sm" w="sm" type="none"/>
-                    </a:lnB>
-                  </a:tcPr>
-                </a:tc>
-                <a:tc>
-                  <a:txBody>
-                    <a:bodyPr/>
-                    <a:lstStyle/>
-                    <a:p>
-                      <a:pPr indent="0" lvl="0" marL="0" rtl="0" algn="ctr">
-                        <a:spcBef>
-                          <a:spcPts val="0"/>
-                        </a:spcBef>
-                        <a:spcAft>
-                          <a:spcPts val="0"/>
-                        </a:spcAft>
-                        <a:buNone/>
-                      </a:pPr>
-                      <a:r>
-                        <a:rPr lang="en">
-                          <a:solidFill>
-                            <a:schemeClr val="lt1"/>
-                          </a:solidFill>
-                        </a:rPr>
-                        <a:t>Yes</a:t>
-                      </a:r>
-                      <a:endParaRPr>
-                        <a:solidFill>
-                          <a:schemeClr val="lt1"/>
-                        </a:solidFill>
-                      </a:endParaRPr>
-                    </a:p>
-                  </a:txBody>
-                  <a:tcPr marT="19050" marB="19050" marR="28575" marL="28575">
-                    <a:lnL cap="flat" cmpd="sng" w="9525">
-                      <a:solidFill>
-                        <a:srgbClr val="CCCCCC"/>
-                      </a:solidFill>
-                      <a:prstDash val="solid"/>
-                      <a:round/>
-                      <a:headEnd len="sm" w="sm" type="none"/>
-                      <a:tailEnd len="sm" w="sm" type="none"/>
-                    </a:lnL>
-                    <a:lnR cap="flat" cmpd="sng" w="9525">
-                      <a:solidFill>
-                        <a:srgbClr val="CCCCCC"/>
-                      </a:solidFill>
-                      <a:prstDash val="solid"/>
-                      <a:round/>
-                      <a:headEnd len="sm" w="sm" type="none"/>
-                      <a:tailEnd len="sm" w="sm" type="none"/>
-                    </a:lnR>
-                    <a:lnT cap="flat" cmpd="sng" w="9525">
-                      <a:solidFill>
-                        <a:srgbClr val="CCCCCC"/>
-                      </a:solidFill>
-                      <a:prstDash val="solid"/>
-                      <a:round/>
-                      <a:headEnd len="sm" w="sm" type="none"/>
-                      <a:tailEnd len="sm" w="sm" type="none"/>
-                    </a:lnT>
-                    <a:lnB cap="flat" cmpd="sng" w="9525">
-                      <a:solidFill>
-                        <a:srgbClr val="CCCCCC"/>
-                      </a:solidFill>
-                      <a:prstDash val="solid"/>
-                      <a:round/>
-                      <a:headEnd len="sm" w="sm" type="none"/>
-                      <a:tailEnd len="sm" w="sm" type="none"/>
-                    </a:lnB>
-                  </a:tcPr>
-                </a:tc>
-                <a:tc>
-                  <a:txBody>
-                    <a:bodyPr/>
-                    <a:lstStyle/>
-                    <a:p>
-                      <a:pPr indent="0" lvl="0" marL="0" rtl="0" algn="l">
-                        <a:spcBef>
-                          <a:spcPts val="0"/>
-                        </a:spcBef>
-                        <a:spcAft>
-                          <a:spcPts val="0"/>
-                        </a:spcAft>
-                        <a:buNone/>
-                      </a:pPr>
-                      <a:r>
-                        <a:t/>
-                      </a:r>
-                      <a:endParaRPr>
-                        <a:solidFill>
-                          <a:schemeClr val="lt1"/>
-                        </a:solidFill>
-                      </a:endParaRPr>
-                    </a:p>
-                  </a:txBody>
-                  <a:tcPr marT="91425" marB="91425" marR="91425" marL="91425">
-                    <a:lnL cap="flat" cmpd="sng" w="9525">
-                      <a:solidFill>
-                        <a:srgbClr val="CCCCCC"/>
-                      </a:solidFill>
-                      <a:prstDash val="solid"/>
-                      <a:round/>
-                      <a:headEnd len="sm" w="sm" type="none"/>
-                      <a:tailEnd len="sm" w="sm" type="none"/>
-                    </a:lnL>
-                    <a:lnR cap="flat" cmpd="sng" w="9525">
-                      <a:solidFill>
-                        <a:srgbClr val="9E9E9E"/>
-                      </a:solidFill>
-                      <a:prstDash val="solid"/>
-                      <a:round/>
-                      <a:headEnd len="sm" w="sm" type="none"/>
-                      <a:tailEnd len="sm" w="sm" type="none"/>
-                    </a:lnR>
-                    <a:lnT cap="flat" cmpd="sng" w="9525">
-                      <a:solidFill>
-                        <a:srgbClr val="9E9E9E"/>
-                      </a:solidFill>
-                      <a:prstDash val="solid"/>
-                      <a:round/>
-                      <a:headEnd len="sm" w="sm" type="none"/>
-                      <a:tailEnd len="sm" w="sm" type="none"/>
-                    </a:lnT>
-                    <a:lnB cap="flat" cmpd="sng" w="9525">
-                      <a:solidFill>
-                        <a:srgbClr val="9E9E9E"/>
-                      </a:solidFill>
-                      <a:prstDash val="solid"/>
-                      <a:round/>
-                      <a:headEnd len="sm" w="sm" type="none"/>
-                      <a:tailEnd len="sm" w="sm" type="none"/>
-                    </a:lnB>
-                  </a:tcPr>
-                </a:tc>
-              </a:tr>
-              <a:tr h="338425">
-                <a:tc>
-                  <a:txBody>
-                    <a:bodyPr/>
-                    <a:lstStyle/>
-                    <a:p>
-                      <a:pPr indent="0" lvl="0" marL="0" rtl="0" algn="l">
-                        <a:spcBef>
-                          <a:spcPts val="0"/>
-                        </a:spcBef>
-                        <a:spcAft>
-                          <a:spcPts val="0"/>
-                        </a:spcAft>
-                        <a:buNone/>
-                      </a:pPr>
-                      <a:r>
-                        <a:rPr lang="en">
-                          <a:solidFill>
-                            <a:schemeClr val="lt1"/>
-                          </a:solidFill>
-                        </a:rPr>
-                        <a:t>Abhishek B</a:t>
-                      </a:r>
-                      <a:endParaRPr>
-                        <a:solidFill>
-                          <a:schemeClr val="lt1"/>
-                        </a:solidFill>
-                      </a:endParaRPr>
-                    </a:p>
-                  </a:txBody>
-                  <a:tcPr marT="91425" marB="91425" marR="91425" marL="91425">
-                    <a:lnL cap="flat" cmpd="sng" w="9525">
-                      <a:solidFill>
-                        <a:srgbClr val="9E9E9E"/>
-                      </a:solidFill>
-                      <a:prstDash val="solid"/>
-                      <a:round/>
-                      <a:headEnd len="sm" w="sm" type="none"/>
-                      <a:tailEnd len="sm" w="sm" type="none"/>
-                    </a:lnL>
-                    <a:lnR cap="flat" cmpd="sng" w="9525">
-                      <a:solidFill>
-                        <a:srgbClr val="9E9E9E"/>
-                      </a:solidFill>
-                      <a:prstDash val="solid"/>
-                      <a:round/>
-                      <a:headEnd len="sm" w="sm" type="none"/>
-                      <a:tailEnd len="sm" w="sm" type="none"/>
-                    </a:lnR>
-                    <a:lnT cap="flat" cmpd="sng" w="9525">
-                      <a:solidFill>
-                        <a:srgbClr val="9E9E9E"/>
-                      </a:solidFill>
-                      <a:prstDash val="solid"/>
-                      <a:round/>
-                      <a:headEnd len="sm" w="sm" type="none"/>
-                      <a:tailEnd len="sm" w="sm" type="none"/>
-                    </a:lnT>
-                    <a:lnB cap="flat" cmpd="sng" w="9525">
-                      <a:solidFill>
-                        <a:srgbClr val="9E9E9E"/>
-                      </a:solidFill>
-                      <a:prstDash val="solid"/>
-                      <a:round/>
-                      <a:headEnd len="sm" w="sm" type="none"/>
-                      <a:tailEnd len="sm" w="sm" type="none"/>
-                    </a:lnB>
-                  </a:tcPr>
-                </a:tc>
-                <a:tc>
-                  <a:txBody>
-                    <a:bodyPr/>
-                    <a:lstStyle/>
-                    <a:p>
-                      <a:pPr indent="0" lvl="0" marL="0" rtl="0" algn="l">
-                        <a:spcBef>
-                          <a:spcPts val="0"/>
-                        </a:spcBef>
-                        <a:spcAft>
-                          <a:spcPts val="0"/>
-                        </a:spcAft>
-                        <a:buNone/>
-                      </a:pPr>
-                      <a:r>
-                        <a:rPr lang="en" sz="1200">
-                          <a:solidFill>
-                            <a:schemeClr val="lt1"/>
-                          </a:solidFill>
-                        </a:rPr>
-                        <a:t>abhishekbhatt006@gmail.com</a:t>
-                      </a:r>
-                      <a:endParaRPr sz="1200">
-                        <a:solidFill>
-                          <a:schemeClr val="lt1"/>
-                        </a:solidFill>
-                      </a:endParaRPr>
-                    </a:p>
-                  </a:txBody>
-                  <a:tcPr marT="91425" marB="91425" marR="91425" marL="91425">
-                    <a:lnL cap="flat" cmpd="sng" w="9525">
-                      <a:solidFill>
-                        <a:srgbClr val="9E9E9E"/>
-                      </a:solidFill>
-                      <a:prstDash val="solid"/>
-                      <a:round/>
-                      <a:headEnd len="sm" w="sm" type="none"/>
-                      <a:tailEnd len="sm" w="sm" type="none"/>
-                    </a:lnL>
-                    <a:lnR cap="flat" cmpd="sng" w="9525">
-                      <a:solidFill>
-                        <a:srgbClr val="9E9E9E"/>
-                      </a:solidFill>
-                      <a:prstDash val="solid"/>
-                      <a:round/>
-                      <a:headEnd len="sm" w="sm" type="none"/>
-                      <a:tailEnd len="sm" w="sm" type="none"/>
-                    </a:lnR>
-                    <a:lnT cap="flat" cmpd="sng" w="9525">
-                      <a:solidFill>
-                        <a:srgbClr val="9E9E9E"/>
-                      </a:solidFill>
-                      <a:prstDash val="solid"/>
-                      <a:round/>
-                      <a:headEnd len="sm" w="sm" type="none"/>
-                      <a:tailEnd len="sm" w="sm" type="none"/>
-                    </a:lnT>
-                    <a:lnB cap="flat" cmpd="sng" w="9525">
-                      <a:solidFill>
-                        <a:srgbClr val="9E9E9E"/>
-                      </a:solidFill>
-                      <a:prstDash val="solid"/>
-                      <a:round/>
-                      <a:headEnd len="sm" w="sm" type="none"/>
-                      <a:tailEnd len="sm" w="sm" type="none"/>
-                    </a:lnB>
-                  </a:tcPr>
-                </a:tc>
-                <a:tc>
-                  <a:txBody>
-                    <a:bodyPr/>
-                    <a:lstStyle/>
-                    <a:p>
-                      <a:pPr indent="0" lvl="0" marL="0" rtl="0" algn="l">
-                        <a:spcBef>
-                          <a:spcPts val="0"/>
-                        </a:spcBef>
-                        <a:spcAft>
-                          <a:spcPts val="0"/>
-                        </a:spcAft>
-                        <a:buNone/>
-                      </a:pPr>
-                      <a:r>
-                        <a:rPr lang="en" sz="1200">
-                          <a:solidFill>
-                            <a:schemeClr val="lt1"/>
-                          </a:solidFill>
-                        </a:rPr>
-                        <a:t>416-317-4960</a:t>
-                      </a:r>
-                      <a:endParaRPr sz="1200">
-                        <a:solidFill>
-                          <a:schemeClr val="lt1"/>
-                        </a:solidFill>
-                      </a:endParaRPr>
-                    </a:p>
-                  </a:txBody>
-                  <a:tcPr marT="91425" marB="91425" marR="91425" marL="91425">
-                    <a:lnL cap="flat" cmpd="sng" w="9525">
-                      <a:solidFill>
-                        <a:srgbClr val="9E9E9E"/>
-                      </a:solidFill>
-                      <a:prstDash val="solid"/>
-                      <a:round/>
-                      <a:headEnd len="sm" w="sm" type="none"/>
-                      <a:tailEnd len="sm" w="sm" type="none"/>
-                    </a:lnL>
-                    <a:lnR cap="flat" cmpd="sng" w="9525">
-                      <a:solidFill>
-                        <a:srgbClr val="CCCCCC"/>
-                      </a:solidFill>
-                      <a:prstDash val="solid"/>
-                      <a:round/>
-                      <a:headEnd len="sm" w="sm" type="none"/>
-                      <a:tailEnd len="sm" w="sm" type="none"/>
-                    </a:lnR>
-                    <a:lnT cap="flat" cmpd="sng" w="9525">
-                      <a:solidFill>
-                        <a:srgbClr val="9E9E9E"/>
-                      </a:solidFill>
-                      <a:prstDash val="solid"/>
-                      <a:round/>
-                      <a:headEnd len="sm" w="sm" type="none"/>
-                      <a:tailEnd len="sm" w="sm" type="none"/>
-                    </a:lnT>
-                    <a:lnB cap="flat" cmpd="sng" w="9525">
-                      <a:solidFill>
-                        <a:srgbClr val="9E9E9E"/>
-                      </a:solidFill>
-                      <a:prstDash val="solid"/>
-                      <a:round/>
-                      <a:headEnd len="sm" w="sm" type="none"/>
-                      <a:tailEnd len="sm" w="sm" type="none"/>
-                    </a:lnB>
-                  </a:tcPr>
-                </a:tc>
-                <a:tc>
-                  <a:txBody>
-                    <a:bodyPr/>
-                    <a:lstStyle/>
-                    <a:p>
-                      <a:pPr indent="0" lvl="0" marL="0" rtl="0" algn="ctr">
-                        <a:spcBef>
-                          <a:spcPts val="0"/>
-                        </a:spcBef>
-                        <a:spcAft>
-                          <a:spcPts val="0"/>
-                        </a:spcAft>
-                        <a:buNone/>
-                      </a:pPr>
-                      <a:r>
-                        <a:rPr lang="en">
-                          <a:solidFill>
-                            <a:schemeClr val="lt1"/>
-                          </a:solidFill>
-                        </a:rPr>
-                        <a:t>Yes</a:t>
-                      </a:r>
-                      <a:endParaRPr>
-                        <a:solidFill>
-                          <a:schemeClr val="lt1"/>
-                        </a:solidFill>
-                      </a:endParaRPr>
-                    </a:p>
-                  </a:txBody>
-                  <a:tcPr marT="19050" marB="19050" marR="28575" marL="28575">
-                    <a:lnL cap="flat" cmpd="sng" w="9525">
-                      <a:solidFill>
-                        <a:srgbClr val="CCCCCC"/>
-                      </a:solidFill>
-                      <a:prstDash val="solid"/>
-                      <a:round/>
-                      <a:headEnd len="sm" w="sm" type="none"/>
-                      <a:tailEnd len="sm" w="sm" type="none"/>
-                    </a:lnL>
-                    <a:lnR cap="flat" cmpd="sng" w="9525">
-                      <a:solidFill>
-                        <a:srgbClr val="CCCCCC"/>
-                      </a:solidFill>
-                      <a:prstDash val="solid"/>
-                      <a:round/>
-                      <a:headEnd len="sm" w="sm" type="none"/>
-                      <a:tailEnd len="sm" w="sm" type="none"/>
-                    </a:lnR>
-                    <a:lnT cap="flat" cmpd="sng" w="9525">
-                      <a:solidFill>
-                        <a:srgbClr val="CCCCCC"/>
-                      </a:solidFill>
-                      <a:prstDash val="solid"/>
-                      <a:round/>
-                      <a:headEnd len="sm" w="sm" type="none"/>
-                      <a:tailEnd len="sm" w="sm" type="none"/>
-                    </a:lnT>
-                    <a:lnB cap="flat" cmpd="sng" w="9525">
-                      <a:solidFill>
-                        <a:srgbClr val="CCCCCC"/>
-                      </a:solidFill>
-                      <a:prstDash val="solid"/>
-                      <a:round/>
-                      <a:headEnd len="sm" w="sm" type="none"/>
-                      <a:tailEnd len="sm" w="sm" type="none"/>
-                    </a:lnB>
-                  </a:tcPr>
-                </a:tc>
-                <a:tc>
-                  <a:txBody>
-                    <a:bodyPr/>
-                    <a:lstStyle/>
-                    <a:p>
-                      <a:pPr indent="0" lvl="0" marL="0" rtl="0" algn="ctr">
-                        <a:spcBef>
-                          <a:spcPts val="0"/>
-                        </a:spcBef>
-                        <a:spcAft>
-                          <a:spcPts val="0"/>
-                        </a:spcAft>
-                        <a:buNone/>
-                      </a:pPr>
-                      <a:r>
-                        <a:rPr lang="en">
-                          <a:solidFill>
-                            <a:schemeClr val="lt1"/>
-                          </a:solidFill>
-                        </a:rPr>
-                        <a:t>Yes</a:t>
-                      </a:r>
-                      <a:endParaRPr>
-                        <a:solidFill>
-                          <a:schemeClr val="lt1"/>
-                        </a:solidFill>
-                      </a:endParaRPr>
-                    </a:p>
-                  </a:txBody>
-                  <a:tcPr marT="19050" marB="19050" marR="28575" marL="28575">
-                    <a:lnL cap="flat" cmpd="sng" w="9525">
-                      <a:solidFill>
-                        <a:srgbClr val="CCCCCC"/>
-                      </a:solidFill>
-                      <a:prstDash val="solid"/>
-                      <a:round/>
-                      <a:headEnd len="sm" w="sm" type="none"/>
-                      <a:tailEnd len="sm" w="sm" type="none"/>
-                    </a:lnL>
-                    <a:lnR cap="flat" cmpd="sng" w="9525">
-                      <a:solidFill>
-                        <a:srgbClr val="CCCCCC"/>
-                      </a:solidFill>
-                      <a:prstDash val="solid"/>
-                      <a:round/>
-                      <a:headEnd len="sm" w="sm" type="none"/>
-                      <a:tailEnd len="sm" w="sm" type="none"/>
-                    </a:lnR>
-                    <a:lnT cap="flat" cmpd="sng" w="9525">
-                      <a:solidFill>
-                        <a:srgbClr val="CCCCCC"/>
-                      </a:solidFill>
-                      <a:prstDash val="solid"/>
-                      <a:round/>
-                      <a:headEnd len="sm" w="sm" type="none"/>
-                      <a:tailEnd len="sm" w="sm" type="none"/>
-                    </a:lnT>
-                    <a:lnB cap="flat" cmpd="sng" w="9525">
-                      <a:solidFill>
-                        <a:srgbClr val="CCCCCC"/>
-                      </a:solidFill>
-                      <a:prstDash val="solid"/>
-                      <a:round/>
-                      <a:headEnd len="sm" w="sm" type="none"/>
-                      <a:tailEnd len="sm" w="sm" type="none"/>
-                    </a:lnB>
-                  </a:tcPr>
-                </a:tc>
-                <a:tc>
-                  <a:txBody>
-                    <a:bodyPr/>
-                    <a:lstStyle/>
-                    <a:p>
-                      <a:pPr indent="0" lvl="0" marL="0" rtl="0" algn="l">
-                        <a:spcBef>
-                          <a:spcPts val="0"/>
-                        </a:spcBef>
-                        <a:spcAft>
-                          <a:spcPts val="0"/>
-                        </a:spcAft>
-                        <a:buNone/>
-                      </a:pPr>
-                      <a:r>
-                        <a:t/>
-                      </a:r>
-                      <a:endParaRPr>
-                        <a:solidFill>
-                          <a:schemeClr val="lt1"/>
-                        </a:solidFill>
-                      </a:endParaRPr>
-                    </a:p>
-                  </a:txBody>
-                  <a:tcPr marT="91425" marB="91425" marR="91425" marL="91425">
-                    <a:lnL cap="flat" cmpd="sng" w="9525">
-                      <a:solidFill>
-                        <a:srgbClr val="CCCCCC"/>
-                      </a:solidFill>
-                      <a:prstDash val="solid"/>
-                      <a:round/>
-                      <a:headEnd len="sm" w="sm" type="none"/>
-                      <a:tailEnd len="sm" w="sm" type="none"/>
-                    </a:lnL>
-                    <a:lnR cap="flat" cmpd="sng" w="9525">
-                      <a:solidFill>
-                        <a:srgbClr val="9E9E9E"/>
-                      </a:solidFill>
-                      <a:prstDash val="solid"/>
-                      <a:round/>
-                      <a:headEnd len="sm" w="sm" type="none"/>
-                      <a:tailEnd len="sm" w="sm" type="none"/>
-                    </a:lnR>
-                    <a:lnT cap="flat" cmpd="sng" w="9525">
-                      <a:solidFill>
-                        <a:srgbClr val="9E9E9E"/>
-                      </a:solidFill>
-                      <a:prstDash val="solid"/>
-                      <a:round/>
-                      <a:headEnd len="sm" w="sm" type="none"/>
-                      <a:tailEnd len="sm" w="sm" type="none"/>
-                    </a:lnT>
-                    <a:lnB cap="flat" cmpd="sng" w="9525">
-                      <a:solidFill>
-                        <a:srgbClr val="9E9E9E"/>
-                      </a:solidFill>
-                      <a:prstDash val="solid"/>
-                      <a:round/>
-                      <a:headEnd len="sm" w="sm" type="none"/>
-                      <a:tailEnd len="sm" w="sm" type="none"/>
-                    </a:lnB>
-                  </a:tcPr>
-                </a:tc>
-              </a:tr>
-              <a:tr h="371775">
-                <a:tc>
-                  <a:txBody>
-                    <a:bodyPr/>
-                    <a:lstStyle/>
-                    <a:p>
-                      <a:pPr indent="0" lvl="0" marL="0" rtl="0" algn="l">
-                        <a:spcBef>
-                          <a:spcPts val="0"/>
-                        </a:spcBef>
-                        <a:spcAft>
-                          <a:spcPts val="0"/>
-                        </a:spcAft>
-                        <a:buNone/>
-                      </a:pPr>
-                      <a:r>
-                        <a:rPr lang="en">
-                          <a:solidFill>
-                            <a:schemeClr val="lt1"/>
-                          </a:solidFill>
-                        </a:rPr>
-                        <a:t>Jaskirat T</a:t>
-                      </a:r>
-                      <a:endParaRPr>
-                        <a:solidFill>
-                          <a:schemeClr val="lt1"/>
-                        </a:solidFill>
-                      </a:endParaRPr>
-                    </a:p>
-                  </a:txBody>
-                  <a:tcPr marT="91425" marB="91425" marR="91425" marL="91425">
-                    <a:lnL cap="flat" cmpd="sng" w="9525">
-                      <a:solidFill>
-                        <a:srgbClr val="9E9E9E"/>
-                      </a:solidFill>
-                      <a:prstDash val="solid"/>
-                      <a:round/>
-                      <a:headEnd len="sm" w="sm" type="none"/>
-                      <a:tailEnd len="sm" w="sm" type="none"/>
-                    </a:lnL>
-                    <a:lnR cap="flat" cmpd="sng" w="9525">
-                      <a:solidFill>
-                        <a:srgbClr val="9E9E9E"/>
-                      </a:solidFill>
-                      <a:prstDash val="solid"/>
-                      <a:round/>
-                      <a:headEnd len="sm" w="sm" type="none"/>
-                      <a:tailEnd len="sm" w="sm" type="none"/>
-                    </a:lnR>
-                    <a:lnT cap="flat" cmpd="sng" w="9525">
-                      <a:solidFill>
-                        <a:srgbClr val="9E9E9E"/>
-                      </a:solidFill>
-                      <a:prstDash val="solid"/>
-                      <a:round/>
-                      <a:headEnd len="sm" w="sm" type="none"/>
-                      <a:tailEnd len="sm" w="sm" type="none"/>
-                    </a:lnT>
-                    <a:lnB cap="flat" cmpd="sng" w="9525">
-                      <a:solidFill>
-                        <a:srgbClr val="9E9E9E"/>
-                      </a:solidFill>
-                      <a:prstDash val="solid"/>
-                      <a:round/>
-                      <a:headEnd len="sm" w="sm" type="none"/>
-                      <a:tailEnd len="sm" w="sm" type="none"/>
-                    </a:lnB>
-                  </a:tcPr>
-                </a:tc>
-                <a:tc>
-                  <a:txBody>
-                    <a:bodyPr/>
-                    <a:lstStyle/>
-                    <a:p>
-                      <a:pPr indent="0" lvl="0" marL="0" rtl="0" algn="l">
-                        <a:spcBef>
-                          <a:spcPts val="0"/>
-                        </a:spcBef>
-                        <a:spcAft>
-                          <a:spcPts val="0"/>
-                        </a:spcAft>
-                        <a:buNone/>
-                      </a:pPr>
-                      <a:r>
-                        <a:rPr lang="en" sz="1200">
-                          <a:solidFill>
-                            <a:schemeClr val="lt1"/>
-                          </a:solidFill>
-                        </a:rPr>
-                        <a:t>jaskiratsingh2431@gmail.com</a:t>
-                      </a:r>
-                      <a:endParaRPr sz="1200">
-                        <a:solidFill>
-                          <a:schemeClr val="lt1"/>
-                        </a:solidFill>
-                      </a:endParaRPr>
-                    </a:p>
-                  </a:txBody>
-                  <a:tcPr marT="91425" marB="91425" marR="91425" marL="91425">
-                    <a:lnL cap="flat" cmpd="sng" w="9525">
-                      <a:solidFill>
-                        <a:srgbClr val="9E9E9E"/>
-                      </a:solidFill>
-                      <a:prstDash val="solid"/>
-                      <a:round/>
-                      <a:headEnd len="sm" w="sm" type="none"/>
-                      <a:tailEnd len="sm" w="sm" type="none"/>
-                    </a:lnL>
-                    <a:lnR cap="flat" cmpd="sng" w="9525">
-                      <a:solidFill>
-                        <a:srgbClr val="9E9E9E"/>
-                      </a:solidFill>
-                      <a:prstDash val="solid"/>
-                      <a:round/>
-                      <a:headEnd len="sm" w="sm" type="none"/>
-                      <a:tailEnd len="sm" w="sm" type="none"/>
-                    </a:lnR>
-                    <a:lnT cap="flat" cmpd="sng" w="9525">
-                      <a:solidFill>
-                        <a:srgbClr val="9E9E9E"/>
-                      </a:solidFill>
-                      <a:prstDash val="solid"/>
-                      <a:round/>
-                      <a:headEnd len="sm" w="sm" type="none"/>
-                      <a:tailEnd len="sm" w="sm" type="none"/>
-                    </a:lnT>
-                    <a:lnB cap="flat" cmpd="sng" w="9525">
-                      <a:solidFill>
-                        <a:srgbClr val="9E9E9E"/>
-                      </a:solidFill>
-                      <a:prstDash val="solid"/>
-                      <a:round/>
-                      <a:headEnd len="sm" w="sm" type="none"/>
-                      <a:tailEnd len="sm" w="sm" type="none"/>
-                    </a:lnB>
-                  </a:tcPr>
-                </a:tc>
-                <a:tc>
-                  <a:txBody>
-                    <a:bodyPr/>
-                    <a:lstStyle/>
-                    <a:p>
-                      <a:pPr indent="0" lvl="0" marL="0" rtl="0" algn="l">
-                        <a:spcBef>
-                          <a:spcPts val="0"/>
-                        </a:spcBef>
-                        <a:spcAft>
-                          <a:spcPts val="0"/>
-                        </a:spcAft>
-                        <a:buNone/>
-                      </a:pPr>
-                      <a:r>
-                        <a:rPr lang="en" sz="1200">
-                          <a:solidFill>
-                            <a:schemeClr val="lt1"/>
-                          </a:solidFill>
-                        </a:rPr>
-                        <a:t>438-921-0001</a:t>
-                      </a:r>
-                      <a:endParaRPr sz="1200">
-                        <a:solidFill>
-                          <a:schemeClr val="lt1"/>
-                        </a:solidFill>
-                      </a:endParaRPr>
-                    </a:p>
-                  </a:txBody>
-                  <a:tcPr marT="91425" marB="91425" marR="91425" marL="91425">
-                    <a:lnL cap="flat" cmpd="sng" w="9525">
-                      <a:solidFill>
-                        <a:srgbClr val="9E9E9E"/>
-                      </a:solidFill>
-                      <a:prstDash val="solid"/>
-                      <a:round/>
-                      <a:headEnd len="sm" w="sm" type="none"/>
-                      <a:tailEnd len="sm" w="sm" type="none"/>
-                    </a:lnL>
-                    <a:lnR cap="flat" cmpd="sng" w="9525">
-                      <a:solidFill>
-                        <a:srgbClr val="CCCCCC"/>
-                      </a:solidFill>
-                      <a:prstDash val="solid"/>
-                      <a:round/>
-                      <a:headEnd len="sm" w="sm" type="none"/>
-                      <a:tailEnd len="sm" w="sm" type="none"/>
-                    </a:lnR>
-                    <a:lnT cap="flat" cmpd="sng" w="9525">
-                      <a:solidFill>
-                        <a:srgbClr val="9E9E9E"/>
-                      </a:solidFill>
-                      <a:prstDash val="solid"/>
-                      <a:round/>
-                      <a:headEnd len="sm" w="sm" type="none"/>
-                      <a:tailEnd len="sm" w="sm" type="none"/>
-                    </a:lnT>
-                    <a:lnB cap="flat" cmpd="sng" w="9525">
-                      <a:solidFill>
-                        <a:srgbClr val="9E9E9E"/>
-                      </a:solidFill>
-                      <a:prstDash val="solid"/>
-                      <a:round/>
-                      <a:headEnd len="sm" w="sm" type="none"/>
-                      <a:tailEnd len="sm" w="sm" type="none"/>
-                    </a:lnB>
-                  </a:tcPr>
-                </a:tc>
-                <a:tc>
-                  <a:txBody>
-                    <a:bodyPr/>
-                    <a:lstStyle/>
-                    <a:p>
-                      <a:pPr indent="0" lvl="0" marL="0" rtl="0" algn="ctr">
-                        <a:spcBef>
-                          <a:spcPts val="0"/>
-                        </a:spcBef>
-                        <a:spcAft>
-                          <a:spcPts val="0"/>
-                        </a:spcAft>
-                        <a:buNone/>
-                      </a:pPr>
-                      <a:r>
-                        <a:rPr lang="en">
-                          <a:solidFill>
-                            <a:schemeClr val="lt1"/>
-                          </a:solidFill>
-                        </a:rPr>
-                        <a:t>Yes</a:t>
-                      </a:r>
-                      <a:endParaRPr>
-                        <a:solidFill>
-                          <a:schemeClr val="lt1"/>
-                        </a:solidFill>
-                      </a:endParaRPr>
-                    </a:p>
-                  </a:txBody>
-                  <a:tcPr marT="19050" marB="19050" marR="28575" marL="28575">
-                    <a:lnL cap="flat" cmpd="sng" w="9525">
-                      <a:solidFill>
-                        <a:srgbClr val="CCCCCC"/>
-                      </a:solidFill>
-                      <a:prstDash val="solid"/>
-                      <a:round/>
-                      <a:headEnd len="sm" w="sm" type="none"/>
-                      <a:tailEnd len="sm" w="sm" type="none"/>
-                    </a:lnL>
-                    <a:lnR cap="flat" cmpd="sng" w="9525">
-                      <a:solidFill>
-                        <a:srgbClr val="CCCCCC"/>
-                      </a:solidFill>
-                      <a:prstDash val="solid"/>
-                      <a:round/>
-                      <a:headEnd len="sm" w="sm" type="none"/>
-                      <a:tailEnd len="sm" w="sm" type="none"/>
-                    </a:lnR>
-                    <a:lnT cap="flat" cmpd="sng" w="9525">
-                      <a:solidFill>
-                        <a:srgbClr val="CCCCCC"/>
-                      </a:solidFill>
-                      <a:prstDash val="solid"/>
-                      <a:round/>
-                      <a:headEnd len="sm" w="sm" type="none"/>
-                      <a:tailEnd len="sm" w="sm" type="none"/>
-                    </a:lnT>
-                    <a:lnB cap="flat" cmpd="sng" w="9525">
-                      <a:solidFill>
-                        <a:srgbClr val="CCCCCC"/>
-                      </a:solidFill>
-                      <a:prstDash val="solid"/>
-                      <a:round/>
-                      <a:headEnd len="sm" w="sm" type="none"/>
-                      <a:tailEnd len="sm" w="sm" type="none"/>
-                    </a:lnB>
-                  </a:tcPr>
-                </a:tc>
-                <a:tc>
-                  <a:txBody>
-                    <a:bodyPr/>
-                    <a:lstStyle/>
-                    <a:p>
-                      <a:pPr indent="0" lvl="0" marL="0" rtl="0" algn="ctr">
-                        <a:spcBef>
-                          <a:spcPts val="0"/>
-                        </a:spcBef>
-                        <a:spcAft>
-                          <a:spcPts val="0"/>
-                        </a:spcAft>
-                        <a:buNone/>
-                      </a:pPr>
-                      <a:r>
-                        <a:rPr lang="en">
-                          <a:solidFill>
-                            <a:schemeClr val="lt1"/>
-                          </a:solidFill>
-                        </a:rPr>
-                        <a:t>Yes</a:t>
-                      </a:r>
-                      <a:endParaRPr>
-                        <a:solidFill>
-                          <a:schemeClr val="lt1"/>
-                        </a:solidFill>
-                      </a:endParaRPr>
-                    </a:p>
-                  </a:txBody>
-                  <a:tcPr marT="19050" marB="19050" marR="28575" marL="28575">
-                    <a:lnL cap="flat" cmpd="sng" w="9525">
-                      <a:solidFill>
-                        <a:srgbClr val="CCCCCC"/>
-                      </a:solidFill>
-                      <a:prstDash val="solid"/>
-                      <a:round/>
-                      <a:headEnd len="sm" w="sm" type="none"/>
-                      <a:tailEnd len="sm" w="sm" type="none"/>
-                    </a:lnL>
-                    <a:lnR cap="flat" cmpd="sng" w="9525">
-                      <a:solidFill>
-                        <a:srgbClr val="CCCCCC"/>
-                      </a:solidFill>
-                      <a:prstDash val="solid"/>
-                      <a:round/>
-                      <a:headEnd len="sm" w="sm" type="none"/>
-                      <a:tailEnd len="sm" w="sm" type="none"/>
-                    </a:lnR>
-                    <a:lnT cap="flat" cmpd="sng" w="9525">
-                      <a:solidFill>
-                        <a:srgbClr val="CCCCCC"/>
-                      </a:solidFill>
-                      <a:prstDash val="solid"/>
-                      <a:round/>
-                      <a:headEnd len="sm" w="sm" type="none"/>
-                      <a:tailEnd len="sm" w="sm" type="none"/>
-                    </a:lnT>
-                    <a:lnB cap="flat" cmpd="sng" w="9525">
-                      <a:solidFill>
-                        <a:srgbClr val="CCCCCC"/>
-                      </a:solidFill>
-                      <a:prstDash val="solid"/>
-                      <a:round/>
-                      <a:headEnd len="sm" w="sm" type="none"/>
-                      <a:tailEnd len="sm" w="sm" type="none"/>
-                    </a:lnB>
-                  </a:tcPr>
-                </a:tc>
-                <a:tc>
-                  <a:txBody>
-                    <a:bodyPr/>
-                    <a:lstStyle/>
-                    <a:p>
-                      <a:pPr indent="0" lvl="0" marL="0" rtl="0" algn="l">
-                        <a:spcBef>
-                          <a:spcPts val="0"/>
-                        </a:spcBef>
-                        <a:spcAft>
-                          <a:spcPts val="0"/>
-                        </a:spcAft>
-                        <a:buNone/>
-                      </a:pPr>
-                      <a:r>
-                        <a:t/>
-                      </a:r>
-                      <a:endParaRPr>
-                        <a:solidFill>
-                          <a:schemeClr val="lt1"/>
-                        </a:solidFill>
-                      </a:endParaRPr>
-                    </a:p>
-                  </a:txBody>
-                  <a:tcPr marT="91425" marB="91425" marR="91425" marL="91425">
-                    <a:lnL cap="flat" cmpd="sng" w="9525">
-                      <a:solidFill>
-                        <a:srgbClr val="CCCCCC"/>
-                      </a:solidFill>
-                      <a:prstDash val="solid"/>
-                      <a:round/>
-                      <a:headEnd len="sm" w="sm" type="none"/>
-                      <a:tailEnd len="sm" w="sm" type="none"/>
-                    </a:lnL>
-                    <a:lnR cap="flat" cmpd="sng" w="9525">
-                      <a:solidFill>
-                        <a:srgbClr val="9E9E9E"/>
-                      </a:solidFill>
-                      <a:prstDash val="solid"/>
-                      <a:round/>
-                      <a:headEnd len="sm" w="sm" type="none"/>
-                      <a:tailEnd len="sm" w="sm" type="none"/>
-                    </a:lnR>
-                    <a:lnT cap="flat" cmpd="sng" w="9525">
-                      <a:solidFill>
-                        <a:srgbClr val="9E9E9E"/>
-                      </a:solidFill>
-                      <a:prstDash val="solid"/>
-                      <a:round/>
-                      <a:headEnd len="sm" w="sm" type="none"/>
-                      <a:tailEnd len="sm" w="sm" type="none"/>
-                    </a:lnT>
-                    <a:lnB cap="flat" cmpd="sng" w="9525">
-                      <a:solidFill>
-                        <a:srgbClr val="9E9E9E"/>
-                      </a:solidFill>
-                      <a:prstDash val="solid"/>
-                      <a:round/>
-                      <a:headEnd len="sm" w="sm" type="none"/>
-                      <a:tailEnd len="sm" w="sm" type="none"/>
-                    </a:lnB>
-                  </a:tcPr>
-                </a:tc>
-              </a:tr>
-            </a:tbl>
-          </a:graphicData>
-        </a:graphic>
-      </p:graphicFrame>
-      <p:sp>
-        <p:nvSpPr>
-          <p:cNvPr id="118" name="Google Shape;118;p28"/>
-          <p:cNvSpPr txBox="1"/>
-          <p:nvPr>
-            <p:ph idx="12" type="sldNum"/>
-          </p:nvPr>
-        </p:nvSpPr>
-        <p:spPr>
-          <a:xfrm>
-            <a:off x="8365633" y="4708887"/>
-            <a:ext cx="548700" cy="393600"/>
-          </a:xfrm>
-          <a:prstGeom prst="rect">
-            <a:avLst/>
-          </a:prstGeom>
-        </p:spPr>
-        <p:txBody>
-          <a:bodyPr anchorCtr="0" anchor="ctr" bIns="91425" lIns="91425" spcFirstLastPara="1" rIns="91425" wrap="square" tIns="91425">
-            <a:normAutofit/>
-          </a:bodyPr>
-          <a:lstStyle/>
-          <a:p>
-            <a:pPr indent="0" lvl="0" marL="0" rtl="0" algn="r">
-              <a:spcBef>
-                <a:spcPts val="0"/>
-              </a:spcBef>
-              <a:spcAft>
-                <a:spcPts val="0"/>
-              </a:spcAft>
-              <a:buNone/>
-            </a:pPr>
-            <a:fld id="{00000000-1234-1234-1234-123412341234}" type="slidenum">
-              <a:rPr lang="en"/>
-              <a:t>‹#›</a:t>
-            </a:fld>
-            <a:endParaRPr/>
-          </a:p>
-        </p:txBody>
-      </p:sp>
-      <p:sp>
-        <p:nvSpPr>
-          <p:cNvPr id="119" name="Google Shape;119;p28"/>
-          <p:cNvSpPr txBox="1"/>
-          <p:nvPr/>
-        </p:nvSpPr>
-        <p:spPr>
-          <a:xfrm>
-            <a:off x="3415450" y="567011"/>
-            <a:ext cx="5330100" cy="682200"/>
-          </a:xfrm>
-          <a:prstGeom prst="rect">
-            <a:avLst/>
-          </a:prstGeom>
-          <a:noFill/>
-          <a:ln>
-            <a:noFill/>
-          </a:ln>
-        </p:spPr>
-        <p:txBody>
-          <a:bodyPr anchorCtr="0" anchor="t" bIns="91425" lIns="91425" spcFirstLastPara="1" rIns="91425" wrap="square" tIns="91425">
-            <a:noAutofit/>
-          </a:bodyPr>
-          <a:lstStyle/>
-          <a:p>
-            <a:pPr indent="0" lvl="0" marL="0" rtl="0" algn="l">
-              <a:lnSpc>
-                <a:spcPct val="115000"/>
-              </a:lnSpc>
-              <a:spcBef>
-                <a:spcPts val="0"/>
-              </a:spcBef>
-              <a:spcAft>
-                <a:spcPts val="0"/>
-              </a:spcAft>
-              <a:buNone/>
-            </a:pPr>
-            <a:r>
-              <a:rPr b="1" lang="en" sz="800">
-                <a:solidFill>
-                  <a:schemeClr val="lt1"/>
-                </a:solidFill>
-                <a:latin typeface="Google Sans Flex"/>
-                <a:ea typeface="Google Sans Flex"/>
-                <a:cs typeface="Google Sans Flex"/>
-                <a:sym typeface="Google Sans Flex"/>
-              </a:rPr>
-              <a:t>Filming Availability: </a:t>
-            </a:r>
-            <a:r>
-              <a:rPr lang="en" sz="800">
-                <a:solidFill>
-                  <a:schemeClr val="lt1"/>
-                </a:solidFill>
-                <a:latin typeface="Google Sans Flex"/>
-                <a:ea typeface="Google Sans Flex"/>
-                <a:cs typeface="Google Sans Flex"/>
-                <a:sym typeface="Google Sans Flex"/>
-              </a:rPr>
-              <a:t>Should your team be selected as the winner, indicate if and when you are able to return to the Opera House between 1-4PM on 10/21 to film a team pitch of your project. </a:t>
-            </a:r>
-            <a:endParaRPr sz="800">
-              <a:solidFill>
-                <a:schemeClr val="lt1"/>
-              </a:solidFill>
-              <a:latin typeface="Google Sans Flex"/>
-              <a:ea typeface="Google Sans Flex"/>
-              <a:cs typeface="Google Sans Flex"/>
-              <a:sym typeface="Google Sans Flex"/>
-            </a:endParaRPr>
-          </a:p>
-          <a:p>
-            <a:pPr indent="0" lvl="0" marL="0" rtl="0" algn="l">
-              <a:lnSpc>
-                <a:spcPct val="115000"/>
-              </a:lnSpc>
-              <a:spcBef>
-                <a:spcPts val="0"/>
-              </a:spcBef>
-              <a:spcAft>
-                <a:spcPts val="0"/>
-              </a:spcAft>
-              <a:buNone/>
-            </a:pPr>
-            <a:r>
-              <a:rPr b="1" lang="en" sz="800">
-                <a:solidFill>
-                  <a:schemeClr val="lt1"/>
-                </a:solidFill>
-                <a:latin typeface="Google Sans Flex"/>
-                <a:ea typeface="Google Sans Flex"/>
-                <a:cs typeface="Google Sans Flex"/>
-                <a:sym typeface="Google Sans Flex"/>
-              </a:rPr>
-              <a:t>Project Sharing: </a:t>
-            </a:r>
-            <a:r>
-              <a:rPr lang="en" sz="800">
-                <a:solidFill>
-                  <a:schemeClr val="lt1"/>
-                </a:solidFill>
-                <a:latin typeface="Google Sans Flex"/>
-                <a:ea typeface="Google Sans Flex"/>
-                <a:cs typeface="Google Sans Flex"/>
-                <a:sym typeface="Google Sans Flex"/>
-              </a:rPr>
-              <a:t>Mark “yes” if you are OK with us sharing what you built with your team at work.</a:t>
-            </a:r>
-            <a:endParaRPr sz="800">
-              <a:solidFill>
-                <a:schemeClr val="lt1"/>
-              </a:solidFill>
-              <a:latin typeface="Google Sans Flex"/>
-              <a:ea typeface="Google Sans Flex"/>
-              <a:cs typeface="Google Sans Flex"/>
-              <a:sym typeface="Google Sans Flex"/>
-            </a:endParaRPr>
-          </a:p>
-          <a:p>
-            <a:pPr indent="0" lvl="0" marL="0" rtl="0" algn="l">
-              <a:lnSpc>
-                <a:spcPct val="115000"/>
-              </a:lnSpc>
-              <a:spcBef>
-                <a:spcPts val="0"/>
-              </a:spcBef>
-              <a:spcAft>
-                <a:spcPts val="0"/>
-              </a:spcAft>
-              <a:buNone/>
-            </a:pPr>
-            <a:r>
-              <a:rPr b="1" lang="en" sz="800">
-                <a:solidFill>
-                  <a:schemeClr val="lt1"/>
-                </a:solidFill>
-                <a:latin typeface="Google Sans Flex"/>
-                <a:ea typeface="Google Sans Flex"/>
-                <a:cs typeface="Google Sans Flex"/>
-                <a:sym typeface="Google Sans Flex"/>
-              </a:rPr>
-              <a:t>Share With: </a:t>
-            </a:r>
-            <a:r>
-              <a:rPr lang="en" sz="800">
-                <a:solidFill>
-                  <a:schemeClr val="lt1"/>
-                </a:solidFill>
-                <a:latin typeface="Google Sans Flex"/>
-                <a:ea typeface="Google Sans Flex"/>
-                <a:cs typeface="Google Sans Flex"/>
-                <a:sym typeface="Google Sans Flex"/>
-              </a:rPr>
-              <a:t>If “yes” to the above, is there anyone specific you’d like us to share it with at work?  Provide email(s).</a:t>
-            </a:r>
-            <a:endParaRPr sz="800">
-              <a:solidFill>
-                <a:schemeClr val="lt1"/>
-              </a:solidFill>
-              <a:latin typeface="Google Sans Flex"/>
-              <a:ea typeface="Google Sans Flex"/>
-              <a:cs typeface="Google Sans Flex"/>
-              <a:sym typeface="Google Sans Flex"/>
-            </a:endParaRPr>
           </a:p>
         </p:txBody>
       </p:sp>

</xml_diff>